<commit_message>
Milestone 1 deck: fix inconsistencies, add ANALYSIS/RECOMMENDATION structure, polish
Slide 2 retitled; slide 3 pick logic made order-derived (no historical pick-type flags); slide 7 option areas aligned to corrected ~9,500 basis; consistent section tags + footers. Co-Authored-By: Claude Opus 4.8 <noreply@anthropic.com>
</commit_message>
<xml_diff>
--- a/deliverables/DHL Group 3 Milestone 1 (v2).pptx
+++ b/deliverables/DHL Group 3 Milestone 1 (v2).pptx
@@ -3603,7 +3603,7 @@
                 </a:solidFill>
                 <a:latin typeface="Calibri"/>
               </a:rPr>
-              <a:t>SKU, Inventory &amp; Order Profile</a:t>
+              <a:t>SKU &amp; Inventory Profile</a:t>
             </a:r>
           </a:p>
         </p:txBody>
@@ -3700,6 +3700,143 @@
       <p:sp>
         <p:nvSpPr>
           <p:cNvPr id="6" name="Rounded Rectangle 5"/>
+          <p:cNvSpPr/>
+          <p:nvPr/>
+        </p:nvSpPr>
+        <p:spPr>
+          <a:xfrm>
+            <a:off x="10411358" y="329184"/>
+            <a:ext cx="1219809" cy="329184"/>
+          </a:xfrm>
+          <a:prstGeom prst="roundRect">
+            <a:avLst>
+              <a:gd name="adj" fmla="val 50000"/>
+            </a:avLst>
+          </a:prstGeom>
+          <a:solidFill>
+            <a:srgbClr val="F3F4F6"/>
+          </a:solidFill>
+          <a:ln>
+            <a:noFill/>
+          </a:ln>
+          <a:effectLst/>
+        </p:spPr>
+        <p:style>
+          <a:lnRef idx="1">
+            <a:schemeClr val="accent1"/>
+          </a:lnRef>
+          <a:fillRef idx="3">
+            <a:schemeClr val="accent1"/>
+          </a:fillRef>
+          <a:effectRef idx="2">
+            <a:schemeClr val="accent1"/>
+          </a:effectRef>
+          <a:fontRef idx="minor">
+            <a:schemeClr val="lt1"/>
+          </a:fontRef>
+        </p:style>
+        <p:txBody>
+          <a:bodyPr rtlCol="0" anchor="ctr"/>
+          <a:lstStyle/>
+          <a:p>
+            <a:pPr algn="ctr"/>
+          </a:p>
+        </p:txBody>
+      </p:sp>
+      <p:sp>
+        <p:nvSpPr>
+          <p:cNvPr id="7" name="Rounded Rectangle 6"/>
+          <p:cNvSpPr/>
+          <p:nvPr/>
+        </p:nvSpPr>
+        <p:spPr>
+          <a:xfrm>
+            <a:off x="10539374" y="457200"/>
+            <a:ext cx="82296" cy="82296"/>
+          </a:xfrm>
+          <a:prstGeom prst="roundRect">
+            <a:avLst>
+              <a:gd name="adj" fmla="val 50000"/>
+            </a:avLst>
+          </a:prstGeom>
+          <a:solidFill>
+            <a:srgbClr val="FFCC00"/>
+          </a:solidFill>
+          <a:ln>
+            <a:noFill/>
+          </a:ln>
+          <a:effectLst/>
+        </p:spPr>
+        <p:style>
+          <a:lnRef idx="1">
+            <a:schemeClr val="accent1"/>
+          </a:lnRef>
+          <a:fillRef idx="3">
+            <a:schemeClr val="accent1"/>
+          </a:fillRef>
+          <a:effectRef idx="2">
+            <a:schemeClr val="accent1"/>
+          </a:effectRef>
+          <a:fontRef idx="minor">
+            <a:schemeClr val="lt1"/>
+          </a:fontRef>
+        </p:style>
+        <p:txBody>
+          <a:bodyPr rtlCol="0" anchor="ctr"/>
+          <a:lstStyle/>
+          <a:p>
+            <a:pPr algn="ctr"/>
+          </a:p>
+        </p:txBody>
+      </p:sp>
+      <p:sp>
+        <p:nvSpPr>
+          <p:cNvPr id="8" name="TextBox 7"/>
+          <p:cNvSpPr txBox="1"/>
+          <p:nvPr/>
+        </p:nvSpPr>
+        <p:spPr>
+          <a:xfrm>
+            <a:off x="10667390" y="329184"/>
+            <a:ext cx="927201" cy="329184"/>
+          </a:xfrm>
+          <a:prstGeom prst="rect">
+            <a:avLst/>
+          </a:prstGeom>
+          <a:noFill/>
+        </p:spPr>
+        <p:txBody>
+          <a:bodyPr wrap="square" anchor="ctr" lIns="54864" rIns="54864" tIns="18288" bIns="18288">
+            <a:spAutoFit/>
+          </a:bodyPr>
+          <a:lstStyle/>
+          <a:p>
+            <a:pPr algn="l">
+              <a:lnSpc>
+                <a:spcPct val="100000"/>
+              </a:lnSpc>
+              <a:spcBef>
+                <a:spcPts val="0"/>
+              </a:spcBef>
+              <a:spcAft>
+                <a:spcPts val="400"/>
+              </a:spcAft>
+            </a:pPr>
+            <a:r>
+              <a:rPr sz="1050" b="1">
+                <a:solidFill>
+                  <a:srgbClr val="D40511"/>
+                </a:solidFill>
+                <a:latin typeface="Calibri"/>
+              </a:rPr>
+              <a:t>ANALYSIS</a:t>
+            </a:r>
+          </a:p>
+        </p:txBody>
+      </p:sp>
+      <p:sp>
+        <p:nvSpPr>
+          <p:cNvPr id="9" name="Rounded Rectangle 8"/>
           <p:cNvSpPr/>
           <p:nvPr/>
         </p:nvSpPr>
@@ -3753,7 +3890,7 @@
       </p:sp>
       <p:sp>
         <p:nvSpPr>
-          <p:cNvPr id="7" name="TextBox 6"/>
+          <p:cNvPr id="10" name="TextBox 9"/>
           <p:cNvSpPr txBox="1"/>
           <p:nvPr/>
         </p:nvSpPr>
@@ -3798,7 +3935,7 @@
       </p:sp>
       <p:sp>
         <p:nvSpPr>
-          <p:cNvPr id="8" name="TextBox 7"/>
+          <p:cNvPr id="11" name="TextBox 10"/>
           <p:cNvSpPr txBox="1"/>
           <p:nvPr/>
         </p:nvSpPr>
@@ -3843,7 +3980,7 @@
       </p:sp>
       <p:sp>
         <p:nvSpPr>
-          <p:cNvPr id="9" name="Rounded Rectangle 8"/>
+          <p:cNvPr id="12" name="Rounded Rectangle 11"/>
           <p:cNvSpPr/>
           <p:nvPr/>
         </p:nvSpPr>
@@ -3897,7 +4034,7 @@
       </p:sp>
       <p:sp>
         <p:nvSpPr>
-          <p:cNvPr id="10" name="TextBox 9"/>
+          <p:cNvPr id="13" name="TextBox 12"/>
           <p:cNvSpPr txBox="1"/>
           <p:nvPr/>
         </p:nvSpPr>
@@ -3942,7 +4079,7 @@
       </p:sp>
       <p:sp>
         <p:nvSpPr>
-          <p:cNvPr id="11" name="TextBox 10"/>
+          <p:cNvPr id="14" name="TextBox 13"/>
           <p:cNvSpPr txBox="1"/>
           <p:nvPr/>
         </p:nvSpPr>
@@ -3987,7 +4124,7 @@
       </p:sp>
       <p:sp>
         <p:nvSpPr>
-          <p:cNvPr id="12" name="Rounded Rectangle 11"/>
+          <p:cNvPr id="15" name="Rounded Rectangle 14"/>
           <p:cNvSpPr/>
           <p:nvPr/>
         </p:nvSpPr>
@@ -4041,7 +4178,7 @@
       </p:sp>
       <p:sp>
         <p:nvSpPr>
-          <p:cNvPr id="13" name="TextBox 12"/>
+          <p:cNvPr id="16" name="TextBox 15"/>
           <p:cNvSpPr txBox="1"/>
           <p:nvPr/>
         </p:nvSpPr>
@@ -4086,7 +4223,7 @@
       </p:sp>
       <p:sp>
         <p:nvSpPr>
-          <p:cNvPr id="14" name="TextBox 13"/>
+          <p:cNvPr id="17" name="TextBox 16"/>
           <p:cNvSpPr txBox="1"/>
           <p:nvPr/>
         </p:nvSpPr>
@@ -4131,7 +4268,7 @@
       </p:sp>
       <p:sp>
         <p:nvSpPr>
-          <p:cNvPr id="15" name="Rounded Rectangle 14"/>
+          <p:cNvPr id="18" name="Rounded Rectangle 17"/>
           <p:cNvSpPr/>
           <p:nvPr/>
         </p:nvSpPr>
@@ -4185,7 +4322,7 @@
       </p:sp>
       <p:sp>
         <p:nvSpPr>
-          <p:cNvPr id="16" name="TextBox 15"/>
+          <p:cNvPr id="19" name="TextBox 18"/>
           <p:cNvSpPr txBox="1"/>
           <p:nvPr/>
         </p:nvSpPr>
@@ -4230,7 +4367,7 @@
       </p:sp>
       <p:sp>
         <p:nvSpPr>
-          <p:cNvPr id="17" name="TextBox 16"/>
+          <p:cNvPr id="20" name="TextBox 19"/>
           <p:cNvSpPr txBox="1"/>
           <p:nvPr/>
         </p:nvSpPr>
@@ -4275,7 +4412,7 @@
       </p:sp>
       <p:sp>
         <p:nvSpPr>
-          <p:cNvPr id="18" name="Rounded Rectangle 17"/>
+          <p:cNvPr id="21" name="Rounded Rectangle 20"/>
           <p:cNvSpPr/>
           <p:nvPr/>
         </p:nvSpPr>
@@ -4329,7 +4466,7 @@
       </p:sp>
       <p:sp>
         <p:nvSpPr>
-          <p:cNvPr id="19" name="TextBox 18"/>
+          <p:cNvPr id="22" name="TextBox 21"/>
           <p:cNvSpPr txBox="1"/>
           <p:nvPr/>
         </p:nvSpPr>
@@ -4374,7 +4511,7 @@
       </p:sp>
       <p:sp>
         <p:nvSpPr>
-          <p:cNvPr id="20" name="TextBox 19"/>
+          <p:cNvPr id="23" name="TextBox 22"/>
           <p:cNvSpPr txBox="1"/>
           <p:nvPr/>
         </p:nvSpPr>
@@ -4419,7 +4556,7 @@
       </p:sp>
       <p:sp>
         <p:nvSpPr>
-          <p:cNvPr id="21" name="Rounded Rectangle 20"/>
+          <p:cNvPr id="24" name="Rounded Rectangle 23"/>
           <p:cNvSpPr/>
           <p:nvPr/>
         </p:nvSpPr>
@@ -4471,7 +4608,7 @@
       </p:sp>
       <p:sp>
         <p:nvSpPr>
-          <p:cNvPr id="22" name="Rounded Rectangle 21"/>
+          <p:cNvPr id="25" name="Rounded Rectangle 24"/>
           <p:cNvSpPr/>
           <p:nvPr/>
         </p:nvSpPr>
@@ -4517,7 +4654,7 @@
       </p:sp>
       <p:sp>
         <p:nvSpPr>
-          <p:cNvPr id="23" name="TextBox 22"/>
+          <p:cNvPr id="26" name="TextBox 25"/>
           <p:cNvSpPr txBox="1"/>
           <p:nvPr/>
         </p:nvSpPr>
@@ -4562,7 +4699,7 @@
       </p:sp>
       <p:sp>
         <p:nvSpPr>
-          <p:cNvPr id="24" name="TextBox 23"/>
+          <p:cNvPr id="27" name="TextBox 26"/>
           <p:cNvSpPr txBox="1"/>
           <p:nvPr/>
         </p:nvSpPr>
@@ -4852,7 +4989,7 @@
       </p:sp>
       <p:sp>
         <p:nvSpPr>
-          <p:cNvPr id="25" name="Rounded Rectangle 24"/>
+          <p:cNvPr id="28" name="Rounded Rectangle 27"/>
           <p:cNvSpPr/>
           <p:nvPr/>
         </p:nvSpPr>
@@ -4904,7 +5041,7 @@
       </p:sp>
       <p:sp>
         <p:nvSpPr>
-          <p:cNvPr id="26" name="Rounded Rectangle 25"/>
+          <p:cNvPr id="29" name="Rounded Rectangle 28"/>
           <p:cNvSpPr/>
           <p:nvPr/>
         </p:nvSpPr>
@@ -4950,7 +5087,7 @@
       </p:sp>
       <p:sp>
         <p:nvSpPr>
-          <p:cNvPr id="27" name="TextBox 26"/>
+          <p:cNvPr id="30" name="TextBox 29"/>
           <p:cNvSpPr txBox="1"/>
           <p:nvPr/>
         </p:nvSpPr>
@@ -4995,7 +5132,7 @@
       </p:sp>
       <p:sp>
         <p:nvSpPr>
-          <p:cNvPr id="28" name="TextBox 27"/>
+          <p:cNvPr id="31" name="TextBox 30"/>
           <p:cNvSpPr txBox="1"/>
           <p:nvPr/>
         </p:nvSpPr>
@@ -5205,29 +5342,74 @@
               <a:t>•  </a:t>
             </a:r>
             <a:r>
+              <a:rPr sz="1250" b="1">
+                <a:solidFill>
+                  <a:srgbClr val="262626"/>
+                </a:solidFill>
+                <a:latin typeface="Calibri"/>
+              </a:rPr>
+              <a:t>11,015 loads across 8,512 locations</a:t>
+            </a:r>
+            <a:r>
               <a:rPr sz="1250" b="0">
                 <a:solidFill>
                   <a:srgbClr val="262626"/>
                 </a:solidFill>
                 <a:latin typeface="Calibri"/>
               </a:rPr>
-              <a:t>Loads &gt; location count → current design already stacks/</a:t>
-            </a:r>
-            <a:r>
-              <a:rPr sz="1250" b="1">
-                <a:solidFill>
-                  <a:srgbClr val="262626"/>
-                </a:solidFill>
-                <a:latin typeface="Calibri"/>
-              </a:rPr>
-              <a:t>honeycombs</a:t>
-            </a:r>
-          </a:p>
-        </p:txBody>
-      </p:sp>
-      <p:sp>
-        <p:nvSpPr>
-          <p:cNvPr id="29" name="TextBox 28"/>
+              <a:t> → some already hold &gt;1 load</a:t>
+            </a:r>
+          </a:p>
+        </p:txBody>
+      </p:sp>
+      <p:sp>
+        <p:nvSpPr>
+          <p:cNvPr id="32" name="TextBox 31"/>
+          <p:cNvSpPr txBox="1"/>
+          <p:nvPr/>
+        </p:nvSpPr>
+        <p:spPr>
+          <a:xfrm>
+            <a:off x="548640" y="6473952"/>
+            <a:ext cx="7772400" cy="274320"/>
+          </a:xfrm>
+          <a:prstGeom prst="rect">
+            <a:avLst/>
+          </a:prstGeom>
+          <a:noFill/>
+        </p:spPr>
+        <p:txBody>
+          <a:bodyPr wrap="square" anchor="t" lIns="54864" rIns="54864" tIns="18288" bIns="18288">
+            <a:spAutoFit/>
+          </a:bodyPr>
+          <a:lstStyle/>
+          <a:p>
+            <a:pPr algn="l">
+              <a:lnSpc>
+                <a:spcPct val="100000"/>
+              </a:lnSpc>
+              <a:spcBef>
+                <a:spcPts val="0"/>
+              </a:spcBef>
+              <a:spcAft>
+                <a:spcPts val="400"/>
+              </a:spcAft>
+            </a:pPr>
+            <a:r>
+              <a:rPr sz="900" b="0">
+                <a:solidFill>
+                  <a:srgbClr val="6B7280"/>
+                </a:solidFill>
+                <a:latin typeface="Calibri"/>
+              </a:rPr>
+              <a:t>Project OTM — Assa Abloy @ DHL Bemmel · Deliverable 1 (Analysis)</a:t>
+            </a:r>
+          </a:p>
+        </p:txBody>
+      </p:sp>
+      <p:sp>
+        <p:nvSpPr>
+          <p:cNvPr id="33" name="TextBox 32"/>
           <p:cNvSpPr txBox="1"/>
           <p:nvPr/>
         </p:nvSpPr>
@@ -5474,6 +5656,143 @@
         </p:nvSpPr>
         <p:spPr>
           <a:xfrm>
+            <a:off x="10411358" y="329184"/>
+            <a:ext cx="1219809" cy="329184"/>
+          </a:xfrm>
+          <a:prstGeom prst="roundRect">
+            <a:avLst>
+              <a:gd name="adj" fmla="val 50000"/>
+            </a:avLst>
+          </a:prstGeom>
+          <a:solidFill>
+            <a:srgbClr val="F3F4F6"/>
+          </a:solidFill>
+          <a:ln>
+            <a:noFill/>
+          </a:ln>
+          <a:effectLst/>
+        </p:spPr>
+        <p:style>
+          <a:lnRef idx="1">
+            <a:schemeClr val="accent1"/>
+          </a:lnRef>
+          <a:fillRef idx="3">
+            <a:schemeClr val="accent1"/>
+          </a:fillRef>
+          <a:effectRef idx="2">
+            <a:schemeClr val="accent1"/>
+          </a:effectRef>
+          <a:fontRef idx="minor">
+            <a:schemeClr val="lt1"/>
+          </a:fontRef>
+        </p:style>
+        <p:txBody>
+          <a:bodyPr rtlCol="0" anchor="ctr"/>
+          <a:lstStyle/>
+          <a:p>
+            <a:pPr algn="ctr"/>
+          </a:p>
+        </p:txBody>
+      </p:sp>
+      <p:sp>
+        <p:nvSpPr>
+          <p:cNvPr id="7" name="Rounded Rectangle 6"/>
+          <p:cNvSpPr/>
+          <p:nvPr/>
+        </p:nvSpPr>
+        <p:spPr>
+          <a:xfrm>
+            <a:off x="10539374" y="457200"/>
+            <a:ext cx="82296" cy="82296"/>
+          </a:xfrm>
+          <a:prstGeom prst="roundRect">
+            <a:avLst>
+              <a:gd name="adj" fmla="val 50000"/>
+            </a:avLst>
+          </a:prstGeom>
+          <a:solidFill>
+            <a:srgbClr val="FFCC00"/>
+          </a:solidFill>
+          <a:ln>
+            <a:noFill/>
+          </a:ln>
+          <a:effectLst/>
+        </p:spPr>
+        <p:style>
+          <a:lnRef idx="1">
+            <a:schemeClr val="accent1"/>
+          </a:lnRef>
+          <a:fillRef idx="3">
+            <a:schemeClr val="accent1"/>
+          </a:fillRef>
+          <a:effectRef idx="2">
+            <a:schemeClr val="accent1"/>
+          </a:effectRef>
+          <a:fontRef idx="minor">
+            <a:schemeClr val="lt1"/>
+          </a:fontRef>
+        </p:style>
+        <p:txBody>
+          <a:bodyPr rtlCol="0" anchor="ctr"/>
+          <a:lstStyle/>
+          <a:p>
+            <a:pPr algn="ctr"/>
+          </a:p>
+        </p:txBody>
+      </p:sp>
+      <p:sp>
+        <p:nvSpPr>
+          <p:cNvPr id="8" name="TextBox 7"/>
+          <p:cNvSpPr txBox="1"/>
+          <p:nvPr/>
+        </p:nvSpPr>
+        <p:spPr>
+          <a:xfrm>
+            <a:off x="10667390" y="329184"/>
+            <a:ext cx="927201" cy="329184"/>
+          </a:xfrm>
+          <a:prstGeom prst="rect">
+            <a:avLst/>
+          </a:prstGeom>
+          <a:noFill/>
+        </p:spPr>
+        <p:txBody>
+          <a:bodyPr wrap="square" anchor="ctr" lIns="54864" rIns="54864" tIns="18288" bIns="18288">
+            <a:spAutoFit/>
+          </a:bodyPr>
+          <a:lstStyle/>
+          <a:p>
+            <a:pPr algn="l">
+              <a:lnSpc>
+                <a:spcPct val="100000"/>
+              </a:lnSpc>
+              <a:spcBef>
+                <a:spcPts val="0"/>
+              </a:spcBef>
+              <a:spcAft>
+                <a:spcPts val="400"/>
+              </a:spcAft>
+            </a:pPr>
+            <a:r>
+              <a:rPr sz="1050" b="1">
+                <a:solidFill>
+                  <a:srgbClr val="D40511"/>
+                </a:solidFill>
+                <a:latin typeface="Calibri"/>
+              </a:rPr>
+              <a:t>ANALYSIS</a:t>
+            </a:r>
+          </a:p>
+        </p:txBody>
+      </p:sp>
+      <p:sp>
+        <p:nvSpPr>
+          <p:cNvPr id="9" name="Rounded Rectangle 8"/>
+          <p:cNvSpPr/>
+          <p:nvPr/>
+        </p:nvSpPr>
+        <p:spPr>
+          <a:xfrm>
             <a:off x="566928" y="1783080"/>
             <a:ext cx="2606040" cy="1051560"/>
           </a:xfrm>
@@ -5522,7 +5841,7 @@
       </p:sp>
       <p:sp>
         <p:nvSpPr>
-          <p:cNvPr id="7" name="TextBox 6"/>
+          <p:cNvPr id="10" name="TextBox 9"/>
           <p:cNvSpPr txBox="1"/>
           <p:nvPr/>
         </p:nvSpPr>
@@ -5567,7 +5886,7 @@
       </p:sp>
       <p:sp>
         <p:nvSpPr>
-          <p:cNvPr id="8" name="TextBox 7"/>
+          <p:cNvPr id="11" name="TextBox 10"/>
           <p:cNvSpPr txBox="1"/>
           <p:nvPr/>
         </p:nvSpPr>
@@ -5612,7 +5931,7 @@
       </p:sp>
       <p:sp>
         <p:nvSpPr>
-          <p:cNvPr id="9" name="Rounded Rectangle 8"/>
+          <p:cNvPr id="12" name="Rounded Rectangle 11"/>
           <p:cNvSpPr/>
           <p:nvPr/>
         </p:nvSpPr>
@@ -5666,7 +5985,7 @@
       </p:sp>
       <p:sp>
         <p:nvSpPr>
-          <p:cNvPr id="10" name="TextBox 9"/>
+          <p:cNvPr id="13" name="TextBox 12"/>
           <p:cNvSpPr txBox="1"/>
           <p:nvPr/>
         </p:nvSpPr>
@@ -5711,7 +6030,7 @@
       </p:sp>
       <p:sp>
         <p:nvSpPr>
-          <p:cNvPr id="11" name="TextBox 10"/>
+          <p:cNvPr id="14" name="TextBox 13"/>
           <p:cNvSpPr txBox="1"/>
           <p:nvPr/>
         </p:nvSpPr>
@@ -5756,7 +6075,7 @@
       </p:sp>
       <p:sp>
         <p:nvSpPr>
-          <p:cNvPr id="12" name="Rounded Rectangle 11"/>
+          <p:cNvPr id="15" name="Rounded Rectangle 14"/>
           <p:cNvSpPr/>
           <p:nvPr/>
         </p:nvSpPr>
@@ -5810,7 +6129,7 @@
       </p:sp>
       <p:sp>
         <p:nvSpPr>
-          <p:cNvPr id="13" name="TextBox 12"/>
+          <p:cNvPr id="16" name="TextBox 15"/>
           <p:cNvSpPr txBox="1"/>
           <p:nvPr/>
         </p:nvSpPr>
@@ -5855,7 +6174,7 @@
       </p:sp>
       <p:sp>
         <p:nvSpPr>
-          <p:cNvPr id="14" name="TextBox 13"/>
+          <p:cNvPr id="17" name="TextBox 16"/>
           <p:cNvSpPr txBox="1"/>
           <p:nvPr/>
         </p:nvSpPr>
@@ -5900,7 +6219,7 @@
       </p:sp>
       <p:sp>
         <p:nvSpPr>
-          <p:cNvPr id="15" name="Rounded Rectangle 14"/>
+          <p:cNvPr id="18" name="Rounded Rectangle 17"/>
           <p:cNvSpPr/>
           <p:nvPr/>
         </p:nvSpPr>
@@ -5954,7 +6273,7 @@
       </p:sp>
       <p:sp>
         <p:nvSpPr>
-          <p:cNvPr id="16" name="TextBox 15"/>
+          <p:cNvPr id="19" name="TextBox 18"/>
           <p:cNvSpPr txBox="1"/>
           <p:nvPr/>
         </p:nvSpPr>
@@ -5999,7 +6318,7 @@
       </p:sp>
       <p:sp>
         <p:nvSpPr>
-          <p:cNvPr id="17" name="TextBox 16"/>
+          <p:cNvPr id="20" name="TextBox 19"/>
           <p:cNvSpPr txBox="1"/>
           <p:nvPr/>
         </p:nvSpPr>
@@ -6044,7 +6363,7 @@
       </p:sp>
       <p:sp>
         <p:nvSpPr>
-          <p:cNvPr id="18" name="Rounded Rectangle 17"/>
+          <p:cNvPr id="21" name="Rounded Rectangle 20"/>
           <p:cNvSpPr/>
           <p:nvPr/>
         </p:nvSpPr>
@@ -6096,7 +6415,7 @@
       </p:sp>
       <p:sp>
         <p:nvSpPr>
-          <p:cNvPr id="19" name="Rounded Rectangle 18"/>
+          <p:cNvPr id="22" name="Rounded Rectangle 21"/>
           <p:cNvSpPr/>
           <p:nvPr/>
         </p:nvSpPr>
@@ -6142,7 +6461,7 @@
       </p:sp>
       <p:sp>
         <p:nvSpPr>
-          <p:cNvPr id="20" name="TextBox 19"/>
+          <p:cNvPr id="23" name="TextBox 22"/>
           <p:cNvSpPr txBox="1"/>
           <p:nvPr/>
         </p:nvSpPr>
@@ -6187,7 +6506,7 @@
       </p:sp>
       <p:sp>
         <p:nvSpPr>
-          <p:cNvPr id="21" name="TextBox 20"/>
+          <p:cNvPr id="24" name="TextBox 23"/>
           <p:cNvSpPr txBox="1"/>
           <p:nvPr/>
         </p:nvSpPr>
@@ -6372,7 +6691,7 @@
                 </a:solidFill>
                 <a:latin typeface="Calibri"/>
               </a:rPr>
-              <a:t>Case-heavy work: </a:t>
+              <a:t>Lines are small: </a:t>
             </a:r>
             <a:r>
               <a:rPr sz="1250" b="1">
@@ -6381,7 +6700,7 @@
                 </a:solidFill>
                 <a:latin typeface="Calibri"/>
               </a:rPr>
-              <a:t>~83% of pick lifts are case/list</a:t>
+              <a:t>median 5 units/line vs ~1,000/pallet</a:t>
             </a:r>
             <a:r>
               <a:rPr sz="1250" b="0">
@@ -6390,7 +6709,7 @@
                 </a:solidFill>
                 <a:latin typeface="Calibri"/>
               </a:rPr>
-              <a:t>, each 16%, pallet 3%</a:t>
+              <a:t> → case &amp; piece, not pallet</a:t>
             </a:r>
           </a:p>
           <a:p>
@@ -6437,7 +6756,7 @@
       </p:sp>
       <p:sp>
         <p:nvSpPr>
-          <p:cNvPr id="22" name="Rounded Rectangle 21"/>
+          <p:cNvPr id="25" name="Rounded Rectangle 24"/>
           <p:cNvSpPr/>
           <p:nvPr/>
         </p:nvSpPr>
@@ -6489,7 +6808,7 @@
       </p:sp>
       <p:sp>
         <p:nvSpPr>
-          <p:cNvPr id="23" name="Rounded Rectangle 22"/>
+          <p:cNvPr id="26" name="Rounded Rectangle 25"/>
           <p:cNvSpPr/>
           <p:nvPr/>
         </p:nvSpPr>
@@ -6535,7 +6854,7 @@
       </p:sp>
       <p:sp>
         <p:nvSpPr>
-          <p:cNvPr id="24" name="TextBox 23"/>
+          <p:cNvPr id="27" name="TextBox 26"/>
           <p:cNvSpPr txBox="1"/>
           <p:nvPr/>
         </p:nvSpPr>
@@ -6580,7 +6899,7 @@
       </p:sp>
       <p:sp>
         <p:nvSpPr>
-          <p:cNvPr id="25" name="TextBox 24"/>
+          <p:cNvPr id="28" name="TextBox 27"/>
           <p:cNvSpPr txBox="1"/>
           <p:nvPr/>
         </p:nvSpPr>
@@ -6790,7 +7109,52 @@
       </p:sp>
       <p:sp>
         <p:nvSpPr>
-          <p:cNvPr id="26" name="TextBox 25"/>
+          <p:cNvPr id="29" name="TextBox 28"/>
+          <p:cNvSpPr txBox="1"/>
+          <p:nvPr/>
+        </p:nvSpPr>
+        <p:spPr>
+          <a:xfrm>
+            <a:off x="548640" y="6473952"/>
+            <a:ext cx="7772400" cy="274320"/>
+          </a:xfrm>
+          <a:prstGeom prst="rect">
+            <a:avLst/>
+          </a:prstGeom>
+          <a:noFill/>
+        </p:spPr>
+        <p:txBody>
+          <a:bodyPr wrap="square" anchor="t" lIns="54864" rIns="54864" tIns="18288" bIns="18288">
+            <a:spAutoFit/>
+          </a:bodyPr>
+          <a:lstStyle/>
+          <a:p>
+            <a:pPr algn="l">
+              <a:lnSpc>
+                <a:spcPct val="100000"/>
+              </a:lnSpc>
+              <a:spcBef>
+                <a:spcPts val="0"/>
+              </a:spcBef>
+              <a:spcAft>
+                <a:spcPts val="400"/>
+              </a:spcAft>
+            </a:pPr>
+            <a:r>
+              <a:rPr sz="900" b="0">
+                <a:solidFill>
+                  <a:srgbClr val="6B7280"/>
+                </a:solidFill>
+                <a:latin typeface="Calibri"/>
+              </a:rPr>
+              <a:t>Project OTM — Assa Abloy @ DHL Bemmel · Deliverable 1 (Analysis)</a:t>
+            </a:r>
+          </a:p>
+        </p:txBody>
+      </p:sp>
+      <p:sp>
+        <p:nvSpPr>
+          <p:cNvPr id="30" name="TextBox 29"/>
           <p:cNvSpPr txBox="1"/>
           <p:nvPr/>
         </p:nvSpPr>
@@ -7029,9 +7393,146 @@
           </a:p>
         </p:txBody>
       </p:sp>
+      <p:sp>
+        <p:nvSpPr>
+          <p:cNvPr id="6" name="Rounded Rectangle 5"/>
+          <p:cNvSpPr/>
+          <p:nvPr/>
+        </p:nvSpPr>
+        <p:spPr>
+          <a:xfrm>
+            <a:off x="10411358" y="329184"/>
+            <a:ext cx="1219809" cy="329184"/>
+          </a:xfrm>
+          <a:prstGeom prst="roundRect">
+            <a:avLst>
+              <a:gd name="adj" fmla="val 50000"/>
+            </a:avLst>
+          </a:prstGeom>
+          <a:solidFill>
+            <a:srgbClr val="F3F4F6"/>
+          </a:solidFill>
+          <a:ln>
+            <a:noFill/>
+          </a:ln>
+          <a:effectLst/>
+        </p:spPr>
+        <p:style>
+          <a:lnRef idx="1">
+            <a:schemeClr val="accent1"/>
+          </a:lnRef>
+          <a:fillRef idx="3">
+            <a:schemeClr val="accent1"/>
+          </a:fillRef>
+          <a:effectRef idx="2">
+            <a:schemeClr val="accent1"/>
+          </a:effectRef>
+          <a:fontRef idx="minor">
+            <a:schemeClr val="lt1"/>
+          </a:fontRef>
+        </p:style>
+        <p:txBody>
+          <a:bodyPr rtlCol="0" anchor="ctr"/>
+          <a:lstStyle/>
+          <a:p>
+            <a:pPr algn="ctr"/>
+          </a:p>
+        </p:txBody>
+      </p:sp>
+      <p:sp>
+        <p:nvSpPr>
+          <p:cNvPr id="7" name="Rounded Rectangle 6"/>
+          <p:cNvSpPr/>
+          <p:nvPr/>
+        </p:nvSpPr>
+        <p:spPr>
+          <a:xfrm>
+            <a:off x="10539374" y="457200"/>
+            <a:ext cx="82296" cy="82296"/>
+          </a:xfrm>
+          <a:prstGeom prst="roundRect">
+            <a:avLst>
+              <a:gd name="adj" fmla="val 50000"/>
+            </a:avLst>
+          </a:prstGeom>
+          <a:solidFill>
+            <a:srgbClr val="FFCC00"/>
+          </a:solidFill>
+          <a:ln>
+            <a:noFill/>
+          </a:ln>
+          <a:effectLst/>
+        </p:spPr>
+        <p:style>
+          <a:lnRef idx="1">
+            <a:schemeClr val="accent1"/>
+          </a:lnRef>
+          <a:fillRef idx="3">
+            <a:schemeClr val="accent1"/>
+          </a:fillRef>
+          <a:effectRef idx="2">
+            <a:schemeClr val="accent1"/>
+          </a:effectRef>
+          <a:fontRef idx="minor">
+            <a:schemeClr val="lt1"/>
+          </a:fontRef>
+        </p:style>
+        <p:txBody>
+          <a:bodyPr rtlCol="0" anchor="ctr"/>
+          <a:lstStyle/>
+          <a:p>
+            <a:pPr algn="ctr"/>
+          </a:p>
+        </p:txBody>
+      </p:sp>
+      <p:sp>
+        <p:nvSpPr>
+          <p:cNvPr id="8" name="TextBox 7"/>
+          <p:cNvSpPr txBox="1"/>
+          <p:nvPr/>
+        </p:nvSpPr>
+        <p:spPr>
+          <a:xfrm>
+            <a:off x="10667390" y="329184"/>
+            <a:ext cx="927201" cy="329184"/>
+          </a:xfrm>
+          <a:prstGeom prst="rect">
+            <a:avLst/>
+          </a:prstGeom>
+          <a:noFill/>
+        </p:spPr>
+        <p:txBody>
+          <a:bodyPr wrap="square" anchor="ctr" lIns="54864" rIns="54864" tIns="18288" bIns="18288">
+            <a:spAutoFit/>
+          </a:bodyPr>
+          <a:lstStyle/>
+          <a:p>
+            <a:pPr algn="l">
+              <a:lnSpc>
+                <a:spcPct val="100000"/>
+              </a:lnSpc>
+              <a:spcBef>
+                <a:spcPts val="0"/>
+              </a:spcBef>
+              <a:spcAft>
+                <a:spcPts val="400"/>
+              </a:spcAft>
+            </a:pPr>
+            <a:r>
+              <a:rPr sz="1050" b="1">
+                <a:solidFill>
+                  <a:srgbClr val="D40511"/>
+                </a:solidFill>
+                <a:latin typeface="Calibri"/>
+              </a:rPr>
+              <a:t>ANALYSIS</a:t>
+            </a:r>
+          </a:p>
+        </p:txBody>
+      </p:sp>
       <p:pic>
         <p:nvPicPr>
-          <p:cNvPr id="6" name="Picture 5" descr="top20.png"/>
+          <p:cNvPr id="9" name="Picture 8" descr="top20.png"/>
           <p:cNvPicPr>
             <a:picLocks noChangeAspect="1"/>
           </p:cNvPicPr>
@@ -7055,7 +7556,7 @@
       </p:pic>
       <p:sp>
         <p:nvSpPr>
-          <p:cNvPr id="7" name="Rounded Rectangle 6"/>
+          <p:cNvPr id="10" name="Rounded Rectangle 9"/>
           <p:cNvSpPr/>
           <p:nvPr/>
         </p:nvSpPr>
@@ -7107,7 +7608,7 @@
       </p:sp>
       <p:sp>
         <p:nvSpPr>
-          <p:cNvPr id="8" name="Rounded Rectangle 7"/>
+          <p:cNvPr id="11" name="Rounded Rectangle 10"/>
           <p:cNvSpPr/>
           <p:nvPr/>
         </p:nvSpPr>
@@ -7153,7 +7654,7 @@
       </p:sp>
       <p:sp>
         <p:nvSpPr>
-          <p:cNvPr id="9" name="TextBox 8"/>
+          <p:cNvPr id="12" name="TextBox 11"/>
           <p:cNvSpPr txBox="1"/>
           <p:nvPr/>
         </p:nvSpPr>
@@ -7198,7 +7699,7 @@
       </p:sp>
       <p:sp>
         <p:nvSpPr>
-          <p:cNvPr id="10" name="TextBox 9"/>
+          <p:cNvPr id="13" name="TextBox 12"/>
           <p:cNvSpPr txBox="1"/>
           <p:nvPr/>
         </p:nvSpPr>
@@ -7341,7 +7842,7 @@
       </p:sp>
       <p:pic>
         <p:nvPicPr>
-          <p:cNvPr id="11" name="Picture 10" descr="pareto.png"/>
+          <p:cNvPr id="14" name="Picture 13" descr="pareto.png"/>
           <p:cNvPicPr>
             <a:picLocks noChangeAspect="1"/>
           </p:cNvPicPr>
@@ -7365,7 +7866,7 @@
       </p:pic>
       <p:sp>
         <p:nvSpPr>
-          <p:cNvPr id="12" name="TextBox 11"/>
+          <p:cNvPr id="15" name="TextBox 14"/>
           <p:cNvSpPr txBox="1"/>
           <p:nvPr/>
         </p:nvSpPr>
@@ -7419,7 +7920,52 @@
       </p:sp>
       <p:sp>
         <p:nvSpPr>
-          <p:cNvPr id="13" name="TextBox 12"/>
+          <p:cNvPr id="16" name="TextBox 15"/>
+          <p:cNvSpPr txBox="1"/>
+          <p:nvPr/>
+        </p:nvSpPr>
+        <p:spPr>
+          <a:xfrm>
+            <a:off x="548640" y="6473952"/>
+            <a:ext cx="7772400" cy="274320"/>
+          </a:xfrm>
+          <a:prstGeom prst="rect">
+            <a:avLst/>
+          </a:prstGeom>
+          <a:noFill/>
+        </p:spPr>
+        <p:txBody>
+          <a:bodyPr wrap="square" anchor="t" lIns="54864" rIns="54864" tIns="18288" bIns="18288">
+            <a:spAutoFit/>
+          </a:bodyPr>
+          <a:lstStyle/>
+          <a:p>
+            <a:pPr algn="l">
+              <a:lnSpc>
+                <a:spcPct val="100000"/>
+              </a:lnSpc>
+              <a:spcBef>
+                <a:spcPts val="0"/>
+              </a:spcBef>
+              <a:spcAft>
+                <a:spcPts val="400"/>
+              </a:spcAft>
+            </a:pPr>
+            <a:r>
+              <a:rPr sz="900" b="0">
+                <a:solidFill>
+                  <a:srgbClr val="6B7280"/>
+                </a:solidFill>
+                <a:latin typeface="Calibri"/>
+              </a:rPr>
+              <a:t>Project OTM — Assa Abloy @ DHL Bemmel · Deliverable 1 (Analysis)</a:t>
+            </a:r>
+          </a:p>
+        </p:txBody>
+      </p:sp>
+      <p:sp>
+        <p:nvSpPr>
+          <p:cNvPr id="17" name="TextBox 16"/>
           <p:cNvSpPr txBox="1"/>
           <p:nvPr/>
         </p:nvSpPr>
@@ -7571,14 +8117,106 @@
       </p:sp>
       <p:sp>
         <p:nvSpPr>
-          <p:cNvPr id="4" name="TextBox 3"/>
+          <p:cNvPr id="4" name="Rounded Rectangle 3"/>
+          <p:cNvSpPr/>
+          <p:nvPr/>
+        </p:nvSpPr>
+        <p:spPr>
+          <a:xfrm>
+            <a:off x="10411358" y="329184"/>
+            <a:ext cx="1219809" cy="329184"/>
+          </a:xfrm>
+          <a:prstGeom prst="roundRect">
+            <a:avLst>
+              <a:gd name="adj" fmla="val 50000"/>
+            </a:avLst>
+          </a:prstGeom>
+          <a:solidFill>
+            <a:srgbClr val="F3F4F6"/>
+          </a:solidFill>
+          <a:ln>
+            <a:noFill/>
+          </a:ln>
+          <a:effectLst/>
+        </p:spPr>
+        <p:style>
+          <a:lnRef idx="1">
+            <a:schemeClr val="accent1"/>
+          </a:lnRef>
+          <a:fillRef idx="3">
+            <a:schemeClr val="accent1"/>
+          </a:fillRef>
+          <a:effectRef idx="2">
+            <a:schemeClr val="accent1"/>
+          </a:effectRef>
+          <a:fontRef idx="minor">
+            <a:schemeClr val="lt1"/>
+          </a:fontRef>
+        </p:style>
+        <p:txBody>
+          <a:bodyPr rtlCol="0" anchor="ctr"/>
+          <a:lstStyle/>
+          <a:p>
+            <a:pPr algn="ctr"/>
+          </a:p>
+        </p:txBody>
+      </p:sp>
+      <p:sp>
+        <p:nvSpPr>
+          <p:cNvPr id="5" name="Rounded Rectangle 4"/>
+          <p:cNvSpPr/>
+          <p:nvPr/>
+        </p:nvSpPr>
+        <p:spPr>
+          <a:xfrm>
+            <a:off x="10539374" y="457200"/>
+            <a:ext cx="82296" cy="82296"/>
+          </a:xfrm>
+          <a:prstGeom prst="roundRect">
+            <a:avLst>
+              <a:gd name="adj" fmla="val 50000"/>
+            </a:avLst>
+          </a:prstGeom>
+          <a:solidFill>
+            <a:srgbClr val="FFCC00"/>
+          </a:solidFill>
+          <a:ln>
+            <a:noFill/>
+          </a:ln>
+          <a:effectLst/>
+        </p:spPr>
+        <p:style>
+          <a:lnRef idx="1">
+            <a:schemeClr val="accent1"/>
+          </a:lnRef>
+          <a:fillRef idx="3">
+            <a:schemeClr val="accent1"/>
+          </a:fillRef>
+          <a:effectRef idx="2">
+            <a:schemeClr val="accent1"/>
+          </a:effectRef>
+          <a:fontRef idx="minor">
+            <a:schemeClr val="lt1"/>
+          </a:fontRef>
+        </p:style>
+        <p:txBody>
+          <a:bodyPr rtlCol="0" anchor="ctr"/>
+          <a:lstStyle/>
+          <a:p>
+            <a:pPr algn="ctr"/>
+          </a:p>
+        </p:txBody>
+      </p:sp>
+      <p:sp>
+        <p:nvSpPr>
+          <p:cNvPr id="6" name="TextBox 5"/>
           <p:cNvSpPr txBox="1"/>
           <p:nvPr/>
         </p:nvSpPr>
         <p:spPr>
           <a:xfrm>
-            <a:off x="566928" y="1234440"/>
-            <a:ext cx="5029200" cy="320040"/>
+            <a:off x="10667390" y="329184"/>
+            <a:ext cx="927201" cy="329184"/>
           </a:xfrm>
           <a:prstGeom prst="rect">
             <a:avLst/>
@@ -7586,7 +8224,7 @@
           <a:noFill/>
         </p:spPr>
         <p:txBody>
-          <a:bodyPr wrap="square" anchor="t" lIns="54864" rIns="54864" tIns="18288" bIns="18288">
+          <a:bodyPr wrap="square" anchor="ctr" lIns="54864" rIns="54864" tIns="18288" bIns="18288">
             <a:spAutoFit/>
           </a:bodyPr>
           <a:lstStyle/>
@@ -7603,51 +8241,27 @@
               </a:spcAft>
             </a:pPr>
             <a:r>
-              <a:rPr sz="1300" b="1">
+              <a:rPr sz="1050" b="1">
                 <a:solidFill>
                   <a:srgbClr val="D40511"/>
                 </a:solidFill>
                 <a:latin typeface="Calibri"/>
               </a:rPr>
-              <a:t>AVERAGE VS PEAK, BY METRIC</a:t>
-            </a:r>
-          </a:p>
-        </p:txBody>
-      </p:sp>
-      <p:pic>
-        <p:nvPicPr>
-          <p:cNvPr id="5" name="Picture 4" descr="peak_chart.png"/>
-          <p:cNvPicPr>
-            <a:picLocks noChangeAspect="1"/>
-          </p:cNvPicPr>
-          <p:nvPr/>
-        </p:nvPicPr>
-        <p:blipFill>
-          <a:blip r:embed="rId2"/>
-          <a:stretch>
-            <a:fillRect/>
-          </a:stretch>
-        </p:blipFill>
-        <p:spPr>
-          <a:xfrm>
-            <a:off x="590813" y="1600200"/>
-            <a:ext cx="5402052" cy="3246120"/>
-          </a:xfrm>
-          <a:prstGeom prst="rect">
-            <a:avLst/>
-          </a:prstGeom>
-        </p:spPr>
-      </p:pic>
-      <p:sp>
-        <p:nvSpPr>
-          <p:cNvPr id="6" name="TextBox 5"/>
+              <a:t>ANALYSIS</a:t>
+            </a:r>
+          </a:p>
+        </p:txBody>
+      </p:sp>
+      <p:sp>
+        <p:nvSpPr>
+          <p:cNvPr id="7" name="TextBox 6"/>
           <p:cNvSpPr txBox="1"/>
           <p:nvPr/>
         </p:nvSpPr>
         <p:spPr>
           <a:xfrm>
-            <a:off x="566928" y="4846320"/>
-            <a:ext cx="5486400" cy="365760"/>
+            <a:off x="566928" y="1234440"/>
+            <a:ext cx="5029200" cy="320040"/>
           </a:xfrm>
           <a:prstGeom prst="rect">
             <a:avLst/>
@@ -7672,27 +8286,51 @@
               </a:spcAft>
             </a:pPr>
             <a:r>
-              <a:rPr sz="1050" b="0">
-                <a:solidFill>
-                  <a:srgbClr val="6B7280"/>
-                </a:solidFill>
-                <a:latin typeface="Calibri"/>
-              </a:rPr>
-              <a:t>Units shown ÷100 so all four metrics sit on a comparable scale.</a:t>
-            </a:r>
-          </a:p>
-        </p:txBody>
-      </p:sp>
-      <p:sp>
-        <p:nvSpPr>
-          <p:cNvPr id="7" name="TextBox 6"/>
+              <a:rPr sz="1300" b="1">
+                <a:solidFill>
+                  <a:srgbClr val="D40511"/>
+                </a:solidFill>
+                <a:latin typeface="Calibri"/>
+              </a:rPr>
+              <a:t>AVERAGE VS PEAK, BY METRIC</a:t>
+            </a:r>
+          </a:p>
+        </p:txBody>
+      </p:sp>
+      <p:pic>
+        <p:nvPicPr>
+          <p:cNvPr id="8" name="Picture 7" descr="peak_chart.png"/>
+          <p:cNvPicPr>
+            <a:picLocks noChangeAspect="1"/>
+          </p:cNvPicPr>
+          <p:nvPr/>
+        </p:nvPicPr>
+        <p:blipFill>
+          <a:blip r:embed="rId2"/>
+          <a:stretch>
+            <a:fillRect/>
+          </a:stretch>
+        </p:blipFill>
+        <p:spPr>
+          <a:xfrm>
+            <a:off x="590813" y="1600200"/>
+            <a:ext cx="5402052" cy="3246120"/>
+          </a:xfrm>
+          <a:prstGeom prst="rect">
+            <a:avLst/>
+          </a:prstGeom>
+        </p:spPr>
+      </p:pic>
+      <p:sp>
+        <p:nvSpPr>
+          <p:cNvPr id="9" name="TextBox 8"/>
           <p:cNvSpPr txBox="1"/>
           <p:nvPr/>
         </p:nvSpPr>
         <p:spPr>
           <a:xfrm>
-            <a:off x="6446520" y="1234440"/>
-            <a:ext cx="5029200" cy="320040"/>
+            <a:off x="566928" y="4846320"/>
+            <a:ext cx="5486400" cy="365760"/>
           </a:xfrm>
           <a:prstGeom prst="rect">
             <a:avLst/>
@@ -7717,6 +8355,51 @@
               </a:spcAft>
             </a:pPr>
             <a:r>
+              <a:rPr sz="1050" b="0">
+                <a:solidFill>
+                  <a:srgbClr val="6B7280"/>
+                </a:solidFill>
+                <a:latin typeface="Calibri"/>
+              </a:rPr>
+              <a:t>Units shown ÷100 so all four metrics sit on a comparable scale.</a:t>
+            </a:r>
+          </a:p>
+        </p:txBody>
+      </p:sp>
+      <p:sp>
+        <p:nvSpPr>
+          <p:cNvPr id="10" name="TextBox 9"/>
+          <p:cNvSpPr txBox="1"/>
+          <p:nvPr/>
+        </p:nvSpPr>
+        <p:spPr>
+          <a:xfrm>
+            <a:off x="6446520" y="1234440"/>
+            <a:ext cx="5029200" cy="320040"/>
+          </a:xfrm>
+          <a:prstGeom prst="rect">
+            <a:avLst/>
+          </a:prstGeom>
+          <a:noFill/>
+        </p:spPr>
+        <p:txBody>
+          <a:bodyPr wrap="square" anchor="t" lIns="54864" rIns="54864" tIns="18288" bIns="18288">
+            <a:spAutoFit/>
+          </a:bodyPr>
+          <a:lstStyle/>
+          <a:p>
+            <a:pPr algn="l">
+              <a:lnSpc>
+                <a:spcPct val="100000"/>
+              </a:lnSpc>
+              <a:spcBef>
+                <a:spcPts val="0"/>
+              </a:spcBef>
+              <a:spcAft>
+                <a:spcPts val="400"/>
+              </a:spcAft>
+            </a:pPr>
+            <a:r>
               <a:rPr sz="1300" b="1">
                 <a:solidFill>
                   <a:srgbClr val="D40511"/>
@@ -7730,7 +8413,7 @@
       </p:sp>
       <p:graphicFrame>
         <p:nvGraphicFramePr>
-          <p:cNvPr id="8" name="Table 7"/>
+          <p:cNvPr id="11" name="Table 10"/>
           <p:cNvGraphicFramePr>
             <a:graphicFrameLocks noGrp="1"/>
           </p:cNvGraphicFramePr>
@@ -8344,7 +9027,7 @@
       </p:graphicFrame>
       <p:sp>
         <p:nvSpPr>
-          <p:cNvPr id="9" name="TextBox 8"/>
+          <p:cNvPr id="12" name="TextBox 11"/>
           <p:cNvSpPr txBox="1"/>
           <p:nvPr/>
         </p:nvSpPr>
@@ -8398,7 +9081,7 @@
       </p:sp>
       <p:sp>
         <p:nvSpPr>
-          <p:cNvPr id="10" name="Rounded Rectangle 9"/>
+          <p:cNvPr id="13" name="Rounded Rectangle 12"/>
           <p:cNvSpPr/>
           <p:nvPr/>
         </p:nvSpPr>
@@ -8450,7 +9133,7 @@
       </p:sp>
       <p:sp>
         <p:nvSpPr>
-          <p:cNvPr id="11" name="Rounded Rectangle 10"/>
+          <p:cNvPr id="14" name="Rounded Rectangle 13"/>
           <p:cNvSpPr/>
           <p:nvPr/>
         </p:nvSpPr>
@@ -8496,7 +9179,7 @@
       </p:sp>
       <p:sp>
         <p:nvSpPr>
-          <p:cNvPr id="12" name="TextBox 11"/>
+          <p:cNvPr id="15" name="TextBox 14"/>
           <p:cNvSpPr txBox="1"/>
           <p:nvPr/>
         </p:nvSpPr>
@@ -8541,7 +9224,7 @@
       </p:sp>
       <p:sp>
         <p:nvSpPr>
-          <p:cNvPr id="13" name="TextBox 12"/>
+          <p:cNvPr id="16" name="TextBox 15"/>
           <p:cNvSpPr txBox="1"/>
           <p:nvPr/>
         </p:nvSpPr>
@@ -8595,7 +9278,7 @@
       </p:sp>
       <p:sp>
         <p:nvSpPr>
-          <p:cNvPr id="14" name="Rounded Rectangle 13"/>
+          <p:cNvPr id="17" name="Rounded Rectangle 16"/>
           <p:cNvSpPr/>
           <p:nvPr/>
         </p:nvSpPr>
@@ -8647,7 +9330,7 @@
       </p:sp>
       <p:sp>
         <p:nvSpPr>
-          <p:cNvPr id="15" name="Rounded Rectangle 14"/>
+          <p:cNvPr id="18" name="Rounded Rectangle 17"/>
           <p:cNvSpPr/>
           <p:nvPr/>
         </p:nvSpPr>
@@ -8693,7 +9376,7 @@
       </p:sp>
       <p:sp>
         <p:nvSpPr>
-          <p:cNvPr id="16" name="TextBox 15"/>
+          <p:cNvPr id="19" name="TextBox 18"/>
           <p:cNvSpPr txBox="1"/>
           <p:nvPr/>
         </p:nvSpPr>
@@ -8738,7 +9421,7 @@
       </p:sp>
       <p:sp>
         <p:nvSpPr>
-          <p:cNvPr id="17" name="TextBox 16"/>
+          <p:cNvPr id="20" name="TextBox 19"/>
           <p:cNvSpPr txBox="1"/>
           <p:nvPr/>
         </p:nvSpPr>
@@ -8792,7 +9475,7 @@
       </p:sp>
       <p:sp>
         <p:nvSpPr>
-          <p:cNvPr id="18" name="TextBox 17"/>
+          <p:cNvPr id="21" name="TextBox 20"/>
           <p:cNvSpPr txBox="1"/>
           <p:nvPr/>
         </p:nvSpPr>
@@ -8837,7 +9520,7 @@
       </p:sp>
       <p:sp>
         <p:nvSpPr>
-          <p:cNvPr id="19" name="TextBox 18"/>
+          <p:cNvPr id="22" name="TextBox 21"/>
           <p:cNvSpPr txBox="1"/>
           <p:nvPr/>
         </p:nvSpPr>
@@ -9084,6 +9767,143 @@
         </p:nvSpPr>
         <p:spPr>
           <a:xfrm>
+            <a:off x="9873691" y="329184"/>
+            <a:ext cx="1757476" cy="329184"/>
+          </a:xfrm>
+          <a:prstGeom prst="roundRect">
+            <a:avLst>
+              <a:gd name="adj" fmla="val 50000"/>
+            </a:avLst>
+          </a:prstGeom>
+          <a:solidFill>
+            <a:srgbClr val="F3F4F6"/>
+          </a:solidFill>
+          <a:ln>
+            <a:noFill/>
+          </a:ln>
+          <a:effectLst/>
+        </p:spPr>
+        <p:style>
+          <a:lnRef idx="1">
+            <a:schemeClr val="accent1"/>
+          </a:lnRef>
+          <a:fillRef idx="3">
+            <a:schemeClr val="accent1"/>
+          </a:fillRef>
+          <a:effectRef idx="2">
+            <a:schemeClr val="accent1"/>
+          </a:effectRef>
+          <a:fontRef idx="minor">
+            <a:schemeClr val="lt1"/>
+          </a:fontRef>
+        </p:style>
+        <p:txBody>
+          <a:bodyPr rtlCol="0" anchor="ctr"/>
+          <a:lstStyle/>
+          <a:p>
+            <a:pPr algn="ctr"/>
+          </a:p>
+        </p:txBody>
+      </p:sp>
+      <p:sp>
+        <p:nvSpPr>
+          <p:cNvPr id="7" name="Rounded Rectangle 6"/>
+          <p:cNvSpPr/>
+          <p:nvPr/>
+        </p:nvSpPr>
+        <p:spPr>
+          <a:xfrm>
+            <a:off x="10001707" y="457200"/>
+            <a:ext cx="82296" cy="82296"/>
+          </a:xfrm>
+          <a:prstGeom prst="roundRect">
+            <a:avLst>
+              <a:gd name="adj" fmla="val 50000"/>
+            </a:avLst>
+          </a:prstGeom>
+          <a:solidFill>
+            <a:srgbClr val="FFCC00"/>
+          </a:solidFill>
+          <a:ln>
+            <a:noFill/>
+          </a:ln>
+          <a:effectLst/>
+        </p:spPr>
+        <p:style>
+          <a:lnRef idx="1">
+            <a:schemeClr val="accent1"/>
+          </a:lnRef>
+          <a:fillRef idx="3">
+            <a:schemeClr val="accent1"/>
+          </a:fillRef>
+          <a:effectRef idx="2">
+            <a:schemeClr val="accent1"/>
+          </a:effectRef>
+          <a:fontRef idx="minor">
+            <a:schemeClr val="lt1"/>
+          </a:fontRef>
+        </p:style>
+        <p:txBody>
+          <a:bodyPr rtlCol="0" anchor="ctr"/>
+          <a:lstStyle/>
+          <a:p>
+            <a:pPr algn="ctr"/>
+          </a:p>
+        </p:txBody>
+      </p:sp>
+      <p:sp>
+        <p:nvSpPr>
+          <p:cNvPr id="8" name="TextBox 7"/>
+          <p:cNvSpPr txBox="1"/>
+          <p:nvPr/>
+        </p:nvSpPr>
+        <p:spPr>
+          <a:xfrm>
+            <a:off x="10129723" y="329184"/>
+            <a:ext cx="1464868" cy="329184"/>
+          </a:xfrm>
+          <a:prstGeom prst="rect">
+            <a:avLst/>
+          </a:prstGeom>
+          <a:noFill/>
+        </p:spPr>
+        <p:txBody>
+          <a:bodyPr wrap="square" anchor="ctr" lIns="54864" rIns="54864" tIns="18288" bIns="18288">
+            <a:spAutoFit/>
+          </a:bodyPr>
+          <a:lstStyle/>
+          <a:p>
+            <a:pPr algn="l">
+              <a:lnSpc>
+                <a:spcPct val="100000"/>
+              </a:lnSpc>
+              <a:spcBef>
+                <a:spcPts val="0"/>
+              </a:spcBef>
+              <a:spcAft>
+                <a:spcPts val="400"/>
+              </a:spcAft>
+            </a:pPr>
+            <a:r>
+              <a:rPr sz="1050" b="1">
+                <a:solidFill>
+                  <a:srgbClr val="D40511"/>
+                </a:solidFill>
+                <a:latin typeface="Calibri"/>
+              </a:rPr>
+              <a:t>RECOMMENDATION</a:t>
+            </a:r>
+          </a:p>
+        </p:txBody>
+      </p:sp>
+      <p:sp>
+        <p:nvSpPr>
+          <p:cNvPr id="9" name="Rounded Rectangle 8"/>
+          <p:cNvSpPr/>
+          <p:nvPr/>
+        </p:nvSpPr>
+        <p:spPr>
+          <a:xfrm>
             <a:off x="566928" y="1783080"/>
             <a:ext cx="2743200" cy="1005840"/>
           </a:xfrm>
@@ -9132,7 +9952,7 @@
       </p:sp>
       <p:sp>
         <p:nvSpPr>
-          <p:cNvPr id="7" name="TextBox 6"/>
+          <p:cNvPr id="10" name="TextBox 9"/>
           <p:cNvSpPr txBox="1"/>
           <p:nvPr/>
         </p:nvSpPr>
@@ -9177,7 +9997,7 @@
       </p:sp>
       <p:sp>
         <p:nvSpPr>
-          <p:cNvPr id="8" name="TextBox 7"/>
+          <p:cNvPr id="11" name="TextBox 10"/>
           <p:cNvSpPr txBox="1"/>
           <p:nvPr/>
         </p:nvSpPr>
@@ -9222,7 +10042,7 @@
       </p:sp>
       <p:sp>
         <p:nvSpPr>
-          <p:cNvPr id="9" name="Rounded Rectangle 8"/>
+          <p:cNvPr id="12" name="Rounded Rectangle 11"/>
           <p:cNvSpPr/>
           <p:nvPr/>
         </p:nvSpPr>
@@ -9276,7 +10096,7 @@
       </p:sp>
       <p:sp>
         <p:nvSpPr>
-          <p:cNvPr id="10" name="TextBox 9"/>
+          <p:cNvPr id="13" name="TextBox 12"/>
           <p:cNvSpPr txBox="1"/>
           <p:nvPr/>
         </p:nvSpPr>
@@ -9321,7 +10141,7 @@
       </p:sp>
       <p:sp>
         <p:nvSpPr>
-          <p:cNvPr id="11" name="TextBox 10"/>
+          <p:cNvPr id="14" name="TextBox 13"/>
           <p:cNvSpPr txBox="1"/>
           <p:nvPr/>
         </p:nvSpPr>
@@ -9366,7 +10186,7 @@
       </p:sp>
       <p:sp>
         <p:nvSpPr>
-          <p:cNvPr id="12" name="Rounded Rectangle 11"/>
+          <p:cNvPr id="15" name="Rounded Rectangle 14"/>
           <p:cNvSpPr/>
           <p:nvPr/>
         </p:nvSpPr>
@@ -9420,7 +10240,7 @@
       </p:sp>
       <p:sp>
         <p:nvSpPr>
-          <p:cNvPr id="13" name="TextBox 12"/>
+          <p:cNvPr id="16" name="TextBox 15"/>
           <p:cNvSpPr txBox="1"/>
           <p:nvPr/>
         </p:nvSpPr>
@@ -9465,7 +10285,7 @@
       </p:sp>
       <p:sp>
         <p:nvSpPr>
-          <p:cNvPr id="14" name="TextBox 13"/>
+          <p:cNvPr id="17" name="TextBox 16"/>
           <p:cNvSpPr txBox="1"/>
           <p:nvPr/>
         </p:nvSpPr>
@@ -9510,7 +10330,7 @@
       </p:sp>
       <p:sp>
         <p:nvSpPr>
-          <p:cNvPr id="15" name="Rounded Rectangle 14"/>
+          <p:cNvPr id="18" name="Rounded Rectangle 17"/>
           <p:cNvSpPr/>
           <p:nvPr/>
         </p:nvSpPr>
@@ -9562,7 +10382,7 @@
       </p:sp>
       <p:sp>
         <p:nvSpPr>
-          <p:cNvPr id="16" name="Rounded Rectangle 15"/>
+          <p:cNvPr id="19" name="Rounded Rectangle 18"/>
           <p:cNvSpPr/>
           <p:nvPr/>
         </p:nvSpPr>
@@ -9608,7 +10428,7 @@
       </p:sp>
       <p:sp>
         <p:nvSpPr>
-          <p:cNvPr id="17" name="TextBox 16"/>
+          <p:cNvPr id="20" name="TextBox 19"/>
           <p:cNvSpPr txBox="1"/>
           <p:nvPr/>
         </p:nvSpPr>
@@ -9653,7 +10473,7 @@
       </p:sp>
       <p:sp>
         <p:nvSpPr>
-          <p:cNvPr id="18" name="TextBox 17"/>
+          <p:cNvPr id="21" name="TextBox 20"/>
           <p:cNvSpPr txBox="1"/>
           <p:nvPr/>
         </p:nvSpPr>
@@ -9845,7 +10665,7 @@
       </p:sp>
       <p:pic>
         <p:nvPicPr>
-          <p:cNvPr id="19" name="Picture 18" descr="feasibility.png"/>
+          <p:cNvPr id="22" name="Picture 21" descr="feasibility.png"/>
           <p:cNvPicPr>
             <a:picLocks noChangeAspect="1"/>
           </p:cNvPicPr>
@@ -9869,7 +10689,7 @@
       </p:pic>
       <p:sp>
         <p:nvSpPr>
-          <p:cNvPr id="20" name="TextBox 19"/>
+          <p:cNvPr id="23" name="TextBox 22"/>
           <p:cNvSpPr txBox="1"/>
           <p:nvPr/>
         </p:nvSpPr>
@@ -9914,7 +10734,7 @@
       </p:sp>
       <p:sp>
         <p:nvSpPr>
-          <p:cNvPr id="21" name="Rounded Rectangle 20"/>
+          <p:cNvPr id="24" name="Rounded Rectangle 23"/>
           <p:cNvSpPr/>
           <p:nvPr/>
         </p:nvSpPr>
@@ -9966,7 +10786,7 @@
       </p:sp>
       <p:sp>
         <p:nvSpPr>
-          <p:cNvPr id="22" name="TextBox 21"/>
+          <p:cNvPr id="25" name="TextBox 24"/>
           <p:cNvSpPr txBox="1"/>
           <p:nvPr/>
         </p:nvSpPr>
@@ -10020,7 +10840,7 @@
       </p:sp>
       <p:sp>
         <p:nvSpPr>
-          <p:cNvPr id="23" name="TextBox 22"/>
+          <p:cNvPr id="26" name="TextBox 25"/>
           <p:cNvSpPr txBox="1"/>
           <p:nvPr/>
         </p:nvSpPr>
@@ -10267,6 +11087,143 @@
         </p:nvSpPr>
         <p:spPr>
           <a:xfrm>
+            <a:off x="9873691" y="329184"/>
+            <a:ext cx="1757476" cy="329184"/>
+          </a:xfrm>
+          <a:prstGeom prst="roundRect">
+            <a:avLst>
+              <a:gd name="adj" fmla="val 50000"/>
+            </a:avLst>
+          </a:prstGeom>
+          <a:solidFill>
+            <a:srgbClr val="F3F4F6"/>
+          </a:solidFill>
+          <a:ln>
+            <a:noFill/>
+          </a:ln>
+          <a:effectLst/>
+        </p:spPr>
+        <p:style>
+          <a:lnRef idx="1">
+            <a:schemeClr val="accent1"/>
+          </a:lnRef>
+          <a:fillRef idx="3">
+            <a:schemeClr val="accent1"/>
+          </a:fillRef>
+          <a:effectRef idx="2">
+            <a:schemeClr val="accent1"/>
+          </a:effectRef>
+          <a:fontRef idx="minor">
+            <a:schemeClr val="lt1"/>
+          </a:fontRef>
+        </p:style>
+        <p:txBody>
+          <a:bodyPr rtlCol="0" anchor="ctr"/>
+          <a:lstStyle/>
+          <a:p>
+            <a:pPr algn="ctr"/>
+          </a:p>
+        </p:txBody>
+      </p:sp>
+      <p:sp>
+        <p:nvSpPr>
+          <p:cNvPr id="7" name="Rounded Rectangle 6"/>
+          <p:cNvSpPr/>
+          <p:nvPr/>
+        </p:nvSpPr>
+        <p:spPr>
+          <a:xfrm>
+            <a:off x="10001707" y="457200"/>
+            <a:ext cx="82296" cy="82296"/>
+          </a:xfrm>
+          <a:prstGeom prst="roundRect">
+            <a:avLst>
+              <a:gd name="adj" fmla="val 50000"/>
+            </a:avLst>
+          </a:prstGeom>
+          <a:solidFill>
+            <a:srgbClr val="FFCC00"/>
+          </a:solidFill>
+          <a:ln>
+            <a:noFill/>
+          </a:ln>
+          <a:effectLst/>
+        </p:spPr>
+        <p:style>
+          <a:lnRef idx="1">
+            <a:schemeClr val="accent1"/>
+          </a:lnRef>
+          <a:fillRef idx="3">
+            <a:schemeClr val="accent1"/>
+          </a:fillRef>
+          <a:effectRef idx="2">
+            <a:schemeClr val="accent1"/>
+          </a:effectRef>
+          <a:fontRef idx="minor">
+            <a:schemeClr val="lt1"/>
+          </a:fontRef>
+        </p:style>
+        <p:txBody>
+          <a:bodyPr rtlCol="0" anchor="ctr"/>
+          <a:lstStyle/>
+          <a:p>
+            <a:pPr algn="ctr"/>
+          </a:p>
+        </p:txBody>
+      </p:sp>
+      <p:sp>
+        <p:nvSpPr>
+          <p:cNvPr id="8" name="TextBox 7"/>
+          <p:cNvSpPr txBox="1"/>
+          <p:nvPr/>
+        </p:nvSpPr>
+        <p:spPr>
+          <a:xfrm>
+            <a:off x="10129723" y="329184"/>
+            <a:ext cx="1464868" cy="329184"/>
+          </a:xfrm>
+          <a:prstGeom prst="rect">
+            <a:avLst/>
+          </a:prstGeom>
+          <a:noFill/>
+        </p:spPr>
+        <p:txBody>
+          <a:bodyPr wrap="square" anchor="ctr" lIns="54864" rIns="54864" tIns="18288" bIns="18288">
+            <a:spAutoFit/>
+          </a:bodyPr>
+          <a:lstStyle/>
+          <a:p>
+            <a:pPr algn="l">
+              <a:lnSpc>
+                <a:spcPct val="100000"/>
+              </a:lnSpc>
+              <a:spcBef>
+                <a:spcPts val="0"/>
+              </a:spcBef>
+              <a:spcAft>
+                <a:spcPts val="400"/>
+              </a:spcAft>
+            </a:pPr>
+            <a:r>
+              <a:rPr sz="1050" b="1">
+                <a:solidFill>
+                  <a:srgbClr val="D40511"/>
+                </a:solidFill>
+                <a:latin typeface="Calibri"/>
+              </a:rPr>
+              <a:t>RECOMMENDATION</a:t>
+            </a:r>
+          </a:p>
+        </p:txBody>
+      </p:sp>
+      <p:sp>
+        <p:nvSpPr>
+          <p:cNvPr id="9" name="Rounded Rectangle 8"/>
+          <p:cNvSpPr/>
+          <p:nvPr/>
+        </p:nvSpPr>
+        <p:spPr>
+          <a:xfrm>
             <a:off x="566928" y="1737360"/>
             <a:ext cx="3246120" cy="1417320"/>
           </a:xfrm>
@@ -10313,7 +11270,7 @@
       </p:sp>
       <p:sp>
         <p:nvSpPr>
-          <p:cNvPr id="7" name="Rounded Rectangle 6"/>
+          <p:cNvPr id="10" name="Rounded Rectangle 9"/>
           <p:cNvSpPr/>
           <p:nvPr/>
         </p:nvSpPr>
@@ -10359,7 +11316,7 @@
       </p:sp>
       <p:sp>
         <p:nvSpPr>
-          <p:cNvPr id="8" name="TextBox 7"/>
+          <p:cNvPr id="11" name="TextBox 10"/>
           <p:cNvSpPr txBox="1"/>
           <p:nvPr/>
         </p:nvSpPr>
@@ -10404,7 +11361,7 @@
       </p:sp>
       <p:sp>
         <p:nvSpPr>
-          <p:cNvPr id="9" name="TextBox 8"/>
+          <p:cNvPr id="12" name="TextBox 11"/>
           <p:cNvSpPr txBox="1"/>
           <p:nvPr/>
         </p:nvSpPr>
@@ -10482,7 +11439,7 @@
                 </a:solidFill>
                 <a:latin typeface="Calibri"/>
               </a:rPr>
-              <a:t>Discrete + batch pick</a:t>
+              <a:t>Discrete + batch picking</a:t>
             </a:r>
           </a:p>
           <a:p>
@@ -10513,7 +11470,7 @@
                 </a:solidFill>
                 <a:latin typeface="Calibri"/>
               </a:rPr>
-              <a:t>~7,500 m² · lowest CAPEX</a:t>
+              <a:t>≈72% of envelope</a:t>
             </a:r>
           </a:p>
           <a:p>
@@ -10544,14 +11501,14 @@
                 </a:solidFill>
                 <a:latin typeface="Calibri"/>
               </a:rPr>
-              <a:t>Highest travel/labour</a:t>
-            </a:r>
-          </a:p>
-        </p:txBody>
-      </p:sp>
-      <p:sp>
-        <p:nvSpPr>
-          <p:cNvPr id="10" name="Rounded Rectangle 9"/>
+              <a:t>Lowest CAPEX · most travel</a:t>
+            </a:r>
+          </a:p>
+        </p:txBody>
+      </p:sp>
+      <p:sp>
+        <p:nvSpPr>
+          <p:cNvPr id="13" name="Rounded Rectangle 12"/>
           <p:cNvSpPr/>
           <p:nvPr/>
         </p:nvSpPr>
@@ -10603,7 +11560,7 @@
       </p:sp>
       <p:sp>
         <p:nvSpPr>
-          <p:cNvPr id="11" name="Rounded Rectangle 10"/>
+          <p:cNvPr id="14" name="Rounded Rectangle 13"/>
           <p:cNvSpPr/>
           <p:nvPr/>
         </p:nvSpPr>
@@ -10649,7 +11606,7 @@
       </p:sp>
       <p:sp>
         <p:nvSpPr>
-          <p:cNvPr id="12" name="TextBox 11"/>
+          <p:cNvPr id="15" name="TextBox 14"/>
           <p:cNvSpPr txBox="1"/>
           <p:nvPr/>
         </p:nvSpPr>
@@ -10694,7 +11651,7 @@
       </p:sp>
       <p:sp>
         <p:nvSpPr>
-          <p:cNvPr id="13" name="TextBox 12"/>
+          <p:cNvPr id="16" name="TextBox 15"/>
           <p:cNvSpPr txBox="1"/>
           <p:nvPr/>
         </p:nvSpPr>
@@ -10772,7 +11729,7 @@
                 </a:solidFill>
                 <a:latin typeface="Calibri"/>
               </a:rPr>
-              <a:t>Zone + batch/wave pick</a:t>
+              <a:t>Zone + batch/wave picking</a:t>
             </a:r>
           </a:p>
           <a:p>
@@ -10803,7 +11760,7 @@
                 </a:solidFill>
                 <a:latin typeface="Calibri"/>
               </a:rPr>
-              <a:t>~6,000–6,400 m²</a:t>
+              <a:t>≈61% of envelope · room to grow</a:t>
             </a:r>
           </a:p>
           <a:p>
@@ -10841,7 +11798,7 @@
       </p:sp>
       <p:sp>
         <p:nvSpPr>
-          <p:cNvPr id="14" name="Rounded Rectangle 13"/>
+          <p:cNvPr id="17" name="Rounded Rectangle 16"/>
           <p:cNvSpPr/>
           <p:nvPr/>
         </p:nvSpPr>
@@ -10893,7 +11850,7 @@
       </p:sp>
       <p:sp>
         <p:nvSpPr>
-          <p:cNvPr id="15" name="Rounded Rectangle 14"/>
+          <p:cNvPr id="18" name="Rounded Rectangle 17"/>
           <p:cNvSpPr/>
           <p:nvPr/>
         </p:nvSpPr>
@@ -10939,7 +11896,7 @@
       </p:sp>
       <p:sp>
         <p:nvSpPr>
-          <p:cNvPr id="16" name="TextBox 15"/>
+          <p:cNvPr id="19" name="TextBox 18"/>
           <p:cNvSpPr txBox="1"/>
           <p:nvPr/>
         </p:nvSpPr>
@@ -10984,7 +11941,7 @@
       </p:sp>
       <p:sp>
         <p:nvSpPr>
-          <p:cNvPr id="17" name="TextBox 16"/>
+          <p:cNvPr id="20" name="TextBox 19"/>
           <p:cNvSpPr txBox="1"/>
           <p:nvPr/>
         </p:nvSpPr>
@@ -11093,7 +12050,7 @@
                 </a:solidFill>
                 <a:latin typeface="Calibri"/>
               </a:rPr>
-              <a:t>~5,000 m² · highest CAPEX</a:t>
+              <a:t>≈48% of envelope (densest)</a:t>
             </a:r>
           </a:p>
           <a:p>
@@ -11124,14 +12081,14 @@
                 </a:solidFill>
                 <a:latin typeface="Calibri"/>
               </a:rPr>
-              <a:t>Most complex</a:t>
-            </a:r>
-          </a:p>
-        </p:txBody>
-      </p:sp>
-      <p:sp>
-        <p:nvSpPr>
-          <p:cNvPr id="18" name="TextBox 17"/>
+              <a:t>Highest CAPEX &amp; complexity</a:t>
+            </a:r>
+          </a:p>
+        </p:txBody>
+      </p:sp>
+      <p:sp>
+        <p:nvSpPr>
+          <p:cNvPr id="21" name="TextBox 20"/>
           <p:cNvSpPr txBox="1"/>
           <p:nvPr/>
         </p:nvSpPr>
@@ -11176,7 +12133,7 @@
       </p:sp>
       <p:sp>
         <p:nvSpPr>
-          <p:cNvPr id="19" name="Rounded Rectangle 18"/>
+          <p:cNvPr id="22" name="Rounded Rectangle 21"/>
           <p:cNvSpPr/>
           <p:nvPr/>
         </p:nvSpPr>
@@ -11222,7 +12179,7 @@
       </p:sp>
       <p:sp>
         <p:nvSpPr>
-          <p:cNvPr id="20" name="TextBox 19"/>
+          <p:cNvPr id="23" name="TextBox 22"/>
           <p:cNvSpPr txBox="1"/>
           <p:nvPr/>
         </p:nvSpPr>
@@ -11267,7 +12224,7 @@
       </p:sp>
       <p:sp>
         <p:nvSpPr>
-          <p:cNvPr id="21" name="TextBox 20"/>
+          <p:cNvPr id="24" name="TextBox 23"/>
           <p:cNvSpPr txBox="1"/>
           <p:nvPr/>
         </p:nvSpPr>
@@ -11312,7 +12269,7 @@
       </p:sp>
       <p:sp>
         <p:nvSpPr>
-          <p:cNvPr id="22" name="Rounded Rectangle 21"/>
+          <p:cNvPr id="25" name="Rounded Rectangle 24"/>
           <p:cNvSpPr/>
           <p:nvPr/>
         </p:nvSpPr>
@@ -11358,7 +12315,7 @@
       </p:sp>
       <p:sp>
         <p:nvSpPr>
-          <p:cNvPr id="23" name="Rounded Rectangle 22"/>
+          <p:cNvPr id="26" name="Rounded Rectangle 25"/>
           <p:cNvSpPr/>
           <p:nvPr/>
         </p:nvSpPr>
@@ -11404,7 +12361,7 @@
       </p:sp>
       <p:sp>
         <p:nvSpPr>
-          <p:cNvPr id="24" name="TextBox 23"/>
+          <p:cNvPr id="27" name="TextBox 26"/>
           <p:cNvSpPr txBox="1"/>
           <p:nvPr/>
         </p:nvSpPr>
@@ -11449,7 +12406,7 @@
       </p:sp>
       <p:sp>
         <p:nvSpPr>
-          <p:cNvPr id="25" name="Rounded Rectangle 24"/>
+          <p:cNvPr id="28" name="Rounded Rectangle 27"/>
           <p:cNvSpPr/>
           <p:nvPr/>
         </p:nvSpPr>
@@ -11495,7 +12452,7 @@
       </p:sp>
       <p:sp>
         <p:nvSpPr>
-          <p:cNvPr id="26" name="TextBox 25"/>
+          <p:cNvPr id="29" name="TextBox 28"/>
           <p:cNvSpPr txBox="1"/>
           <p:nvPr/>
         </p:nvSpPr>
@@ -11540,7 +12497,7 @@
       </p:sp>
       <p:sp>
         <p:nvSpPr>
-          <p:cNvPr id="27" name="TextBox 26"/>
+          <p:cNvPr id="30" name="TextBox 29"/>
           <p:cNvSpPr txBox="1"/>
           <p:nvPr/>
         </p:nvSpPr>
@@ -11585,7 +12542,7 @@
       </p:sp>
       <p:sp>
         <p:nvSpPr>
-          <p:cNvPr id="28" name="Rounded Rectangle 27"/>
+          <p:cNvPr id="31" name="Rounded Rectangle 30"/>
           <p:cNvSpPr/>
           <p:nvPr/>
         </p:nvSpPr>
@@ -11631,7 +12588,7 @@
       </p:sp>
       <p:sp>
         <p:nvSpPr>
-          <p:cNvPr id="29" name="Rounded Rectangle 28"/>
+          <p:cNvPr id="32" name="Rounded Rectangle 31"/>
           <p:cNvSpPr/>
           <p:nvPr/>
         </p:nvSpPr>
@@ -11677,7 +12634,7 @@
       </p:sp>
       <p:sp>
         <p:nvSpPr>
-          <p:cNvPr id="30" name="TextBox 29"/>
+          <p:cNvPr id="33" name="TextBox 32"/>
           <p:cNvSpPr txBox="1"/>
           <p:nvPr/>
         </p:nvSpPr>
@@ -11722,7 +12679,7 @@
       </p:sp>
       <p:sp>
         <p:nvSpPr>
-          <p:cNvPr id="31" name="Rounded Rectangle 30"/>
+          <p:cNvPr id="34" name="Rounded Rectangle 33"/>
           <p:cNvSpPr/>
           <p:nvPr/>
         </p:nvSpPr>
@@ -11768,7 +12725,7 @@
       </p:sp>
       <p:sp>
         <p:nvSpPr>
-          <p:cNvPr id="32" name="TextBox 31"/>
+          <p:cNvPr id="35" name="TextBox 34"/>
           <p:cNvSpPr txBox="1"/>
           <p:nvPr/>
         </p:nvSpPr>
@@ -11813,7 +12770,7 @@
       </p:sp>
       <p:sp>
         <p:nvSpPr>
-          <p:cNvPr id="33" name="TextBox 32"/>
+          <p:cNvPr id="36" name="TextBox 35"/>
           <p:cNvSpPr txBox="1"/>
           <p:nvPr/>
         </p:nvSpPr>
@@ -11858,7 +12815,7 @@
       </p:sp>
       <p:sp>
         <p:nvSpPr>
-          <p:cNvPr id="34" name="Rounded Rectangle 33"/>
+          <p:cNvPr id="37" name="Rounded Rectangle 36"/>
           <p:cNvSpPr/>
           <p:nvPr/>
         </p:nvSpPr>
@@ -11904,7 +12861,7 @@
       </p:sp>
       <p:sp>
         <p:nvSpPr>
-          <p:cNvPr id="35" name="Rounded Rectangle 34"/>
+          <p:cNvPr id="38" name="Rounded Rectangle 37"/>
           <p:cNvSpPr/>
           <p:nvPr/>
         </p:nvSpPr>
@@ -11950,7 +12907,7 @@
       </p:sp>
       <p:sp>
         <p:nvSpPr>
-          <p:cNvPr id="36" name="TextBox 35"/>
+          <p:cNvPr id="39" name="TextBox 38"/>
           <p:cNvSpPr txBox="1"/>
           <p:nvPr/>
         </p:nvSpPr>
@@ -11995,7 +12952,7 @@
       </p:sp>
       <p:sp>
         <p:nvSpPr>
-          <p:cNvPr id="37" name="Rounded Rectangle 36"/>
+          <p:cNvPr id="40" name="Rounded Rectangle 39"/>
           <p:cNvSpPr/>
           <p:nvPr/>
         </p:nvSpPr>
@@ -12041,7 +12998,7 @@
       </p:sp>
       <p:sp>
         <p:nvSpPr>
-          <p:cNvPr id="38" name="TextBox 37"/>
+          <p:cNvPr id="41" name="TextBox 40"/>
           <p:cNvSpPr txBox="1"/>
           <p:nvPr/>
         </p:nvSpPr>
@@ -12086,7 +13043,7 @@
       </p:sp>
       <p:sp>
         <p:nvSpPr>
-          <p:cNvPr id="39" name="TextBox 38"/>
+          <p:cNvPr id="42" name="TextBox 41"/>
           <p:cNvSpPr txBox="1"/>
           <p:nvPr/>
         </p:nvSpPr>
@@ -12131,7 +13088,7 @@
       </p:sp>
       <p:sp>
         <p:nvSpPr>
-          <p:cNvPr id="40" name="Rounded Rectangle 39"/>
+          <p:cNvPr id="43" name="Rounded Rectangle 42"/>
           <p:cNvSpPr/>
           <p:nvPr/>
         </p:nvSpPr>
@@ -12177,7 +13134,7 @@
       </p:sp>
       <p:sp>
         <p:nvSpPr>
-          <p:cNvPr id="41" name="Rounded Rectangle 40"/>
+          <p:cNvPr id="44" name="Rounded Rectangle 43"/>
           <p:cNvSpPr/>
           <p:nvPr/>
         </p:nvSpPr>
@@ -12223,7 +13180,7 @@
       </p:sp>
       <p:sp>
         <p:nvSpPr>
-          <p:cNvPr id="42" name="TextBox 41"/>
+          <p:cNvPr id="45" name="TextBox 44"/>
           <p:cNvSpPr txBox="1"/>
           <p:nvPr/>
         </p:nvSpPr>
@@ -12268,7 +13225,7 @@
       </p:sp>
       <p:sp>
         <p:nvSpPr>
-          <p:cNvPr id="43" name="Rounded Rectangle 42"/>
+          <p:cNvPr id="46" name="Rounded Rectangle 45"/>
           <p:cNvSpPr/>
           <p:nvPr/>
         </p:nvSpPr>
@@ -12314,7 +13271,7 @@
       </p:sp>
       <p:sp>
         <p:nvSpPr>
-          <p:cNvPr id="44" name="TextBox 43"/>
+          <p:cNvPr id="47" name="TextBox 46"/>
           <p:cNvSpPr txBox="1"/>
           <p:nvPr/>
         </p:nvSpPr>
@@ -12359,7 +13316,7 @@
       </p:sp>
       <p:sp>
         <p:nvSpPr>
-          <p:cNvPr id="45" name="TextBox 44"/>
+          <p:cNvPr id="48" name="TextBox 47"/>
           <p:cNvSpPr txBox="1"/>
           <p:nvPr/>
         </p:nvSpPr>
@@ -12404,7 +13361,7 @@
       </p:sp>
       <p:sp>
         <p:nvSpPr>
-          <p:cNvPr id="46" name="Rounded Rectangle 45"/>
+          <p:cNvPr id="49" name="Rounded Rectangle 48"/>
           <p:cNvSpPr/>
           <p:nvPr/>
         </p:nvSpPr>
@@ -12450,7 +13407,7 @@
       </p:sp>
       <p:sp>
         <p:nvSpPr>
-          <p:cNvPr id="47" name="Rounded Rectangle 46"/>
+          <p:cNvPr id="50" name="Rounded Rectangle 49"/>
           <p:cNvSpPr/>
           <p:nvPr/>
         </p:nvSpPr>
@@ -12496,7 +13453,7 @@
       </p:sp>
       <p:sp>
         <p:nvSpPr>
-          <p:cNvPr id="48" name="TextBox 47"/>
+          <p:cNvPr id="51" name="TextBox 50"/>
           <p:cNvSpPr txBox="1"/>
           <p:nvPr/>
         </p:nvSpPr>
@@ -12541,7 +13498,7 @@
       </p:sp>
       <p:sp>
         <p:nvSpPr>
-          <p:cNvPr id="49" name="Rounded Rectangle 48"/>
+          <p:cNvPr id="52" name="Rounded Rectangle 51"/>
           <p:cNvSpPr/>
           <p:nvPr/>
         </p:nvSpPr>
@@ -12587,7 +13544,7 @@
       </p:sp>
       <p:sp>
         <p:nvSpPr>
-          <p:cNvPr id="50" name="TextBox 49"/>
+          <p:cNvPr id="53" name="TextBox 52"/>
           <p:cNvSpPr txBox="1"/>
           <p:nvPr/>
         </p:nvSpPr>
@@ -12632,7 +13589,7 @@
       </p:sp>
       <p:sp>
         <p:nvSpPr>
-          <p:cNvPr id="51" name="TextBox 50"/>
+          <p:cNvPr id="54" name="TextBox 53"/>
           <p:cNvSpPr txBox="1"/>
           <p:nvPr/>
         </p:nvSpPr>
@@ -12677,7 +13634,7 @@
       </p:sp>
       <p:sp>
         <p:nvSpPr>
-          <p:cNvPr id="52" name="Rounded Rectangle 51"/>
+          <p:cNvPr id="55" name="Rounded Rectangle 54"/>
           <p:cNvSpPr/>
           <p:nvPr/>
         </p:nvSpPr>
@@ -12723,7 +13680,7 @@
       </p:sp>
       <p:sp>
         <p:nvSpPr>
-          <p:cNvPr id="53" name="Rounded Rectangle 52"/>
+          <p:cNvPr id="56" name="Rounded Rectangle 55"/>
           <p:cNvSpPr/>
           <p:nvPr/>
         </p:nvSpPr>
@@ -12769,7 +13726,7 @@
       </p:sp>
       <p:sp>
         <p:nvSpPr>
-          <p:cNvPr id="54" name="TextBox 53"/>
+          <p:cNvPr id="57" name="TextBox 56"/>
           <p:cNvSpPr txBox="1"/>
           <p:nvPr/>
         </p:nvSpPr>
@@ -12814,7 +13771,52 @@
       </p:sp>
       <p:sp>
         <p:nvSpPr>
-          <p:cNvPr id="55" name="TextBox 54"/>
+          <p:cNvPr id="58" name="TextBox 57"/>
+          <p:cNvSpPr txBox="1"/>
+          <p:nvPr/>
+        </p:nvSpPr>
+        <p:spPr>
+          <a:xfrm>
+            <a:off x="548640" y="6473952"/>
+            <a:ext cx="7772400" cy="274320"/>
+          </a:xfrm>
+          <a:prstGeom prst="rect">
+            <a:avLst/>
+          </a:prstGeom>
+          <a:noFill/>
+        </p:spPr>
+        <p:txBody>
+          <a:bodyPr wrap="square" anchor="t" lIns="54864" rIns="54864" tIns="18288" bIns="18288">
+            <a:spAutoFit/>
+          </a:bodyPr>
+          <a:lstStyle/>
+          <a:p>
+            <a:pPr algn="l">
+              <a:lnSpc>
+                <a:spcPct val="100000"/>
+              </a:lnSpc>
+              <a:spcBef>
+                <a:spcPts val="0"/>
+              </a:spcBef>
+              <a:spcAft>
+                <a:spcPts val="400"/>
+              </a:spcAft>
+            </a:pPr>
+            <a:r>
+              <a:rPr sz="900" b="0">
+                <a:solidFill>
+                  <a:srgbClr val="6B7280"/>
+                </a:solidFill>
+                <a:latin typeface="Calibri"/>
+              </a:rPr>
+              <a:t>Project OTM — Assa Abloy @ DHL Bemmel · Deliverable 1 (Analysis)</a:t>
+            </a:r>
+          </a:p>
+        </p:txBody>
+      </p:sp>
+      <p:sp>
+        <p:nvSpPr>
+          <p:cNvPr id="59" name="TextBox 58"/>
           <p:cNvSpPr txBox="1"/>
           <p:nvPr/>
         </p:nvSpPr>
@@ -13053,9 +14055,146 @@
           </a:p>
         </p:txBody>
       </p:sp>
+      <p:sp>
+        <p:nvSpPr>
+          <p:cNvPr id="6" name="Rounded Rectangle 5"/>
+          <p:cNvSpPr/>
+          <p:nvPr/>
+        </p:nvSpPr>
+        <p:spPr>
+          <a:xfrm>
+            <a:off x="9873691" y="329184"/>
+            <a:ext cx="1757476" cy="329184"/>
+          </a:xfrm>
+          <a:prstGeom prst="roundRect">
+            <a:avLst>
+              <a:gd name="adj" fmla="val 50000"/>
+            </a:avLst>
+          </a:prstGeom>
+          <a:solidFill>
+            <a:srgbClr val="F3F4F6"/>
+          </a:solidFill>
+          <a:ln>
+            <a:noFill/>
+          </a:ln>
+          <a:effectLst/>
+        </p:spPr>
+        <p:style>
+          <a:lnRef idx="1">
+            <a:schemeClr val="accent1"/>
+          </a:lnRef>
+          <a:fillRef idx="3">
+            <a:schemeClr val="accent1"/>
+          </a:fillRef>
+          <a:effectRef idx="2">
+            <a:schemeClr val="accent1"/>
+          </a:effectRef>
+          <a:fontRef idx="minor">
+            <a:schemeClr val="lt1"/>
+          </a:fontRef>
+        </p:style>
+        <p:txBody>
+          <a:bodyPr rtlCol="0" anchor="ctr"/>
+          <a:lstStyle/>
+          <a:p>
+            <a:pPr algn="ctr"/>
+          </a:p>
+        </p:txBody>
+      </p:sp>
+      <p:sp>
+        <p:nvSpPr>
+          <p:cNvPr id="7" name="Rounded Rectangle 6"/>
+          <p:cNvSpPr/>
+          <p:nvPr/>
+        </p:nvSpPr>
+        <p:spPr>
+          <a:xfrm>
+            <a:off x="10001707" y="457200"/>
+            <a:ext cx="82296" cy="82296"/>
+          </a:xfrm>
+          <a:prstGeom prst="roundRect">
+            <a:avLst>
+              <a:gd name="adj" fmla="val 50000"/>
+            </a:avLst>
+          </a:prstGeom>
+          <a:solidFill>
+            <a:srgbClr val="FFCC00"/>
+          </a:solidFill>
+          <a:ln>
+            <a:noFill/>
+          </a:ln>
+          <a:effectLst/>
+        </p:spPr>
+        <p:style>
+          <a:lnRef idx="1">
+            <a:schemeClr val="accent1"/>
+          </a:lnRef>
+          <a:fillRef idx="3">
+            <a:schemeClr val="accent1"/>
+          </a:fillRef>
+          <a:effectRef idx="2">
+            <a:schemeClr val="accent1"/>
+          </a:effectRef>
+          <a:fontRef idx="minor">
+            <a:schemeClr val="lt1"/>
+          </a:fontRef>
+        </p:style>
+        <p:txBody>
+          <a:bodyPr rtlCol="0" anchor="ctr"/>
+          <a:lstStyle/>
+          <a:p>
+            <a:pPr algn="ctr"/>
+          </a:p>
+        </p:txBody>
+      </p:sp>
+      <p:sp>
+        <p:nvSpPr>
+          <p:cNvPr id="8" name="TextBox 7"/>
+          <p:cNvSpPr txBox="1"/>
+          <p:nvPr/>
+        </p:nvSpPr>
+        <p:spPr>
+          <a:xfrm>
+            <a:off x="10129723" y="329184"/>
+            <a:ext cx="1464868" cy="329184"/>
+          </a:xfrm>
+          <a:prstGeom prst="rect">
+            <a:avLst/>
+          </a:prstGeom>
+          <a:noFill/>
+        </p:spPr>
+        <p:txBody>
+          <a:bodyPr wrap="square" anchor="ctr" lIns="54864" rIns="54864" tIns="18288" bIns="18288">
+            <a:spAutoFit/>
+          </a:bodyPr>
+          <a:lstStyle/>
+          <a:p>
+            <a:pPr algn="l">
+              <a:lnSpc>
+                <a:spcPct val="100000"/>
+              </a:lnSpc>
+              <a:spcBef>
+                <a:spcPts val="0"/>
+              </a:spcBef>
+              <a:spcAft>
+                <a:spcPts val="400"/>
+              </a:spcAft>
+            </a:pPr>
+            <a:r>
+              <a:rPr sz="1050" b="1">
+                <a:solidFill>
+                  <a:srgbClr val="D40511"/>
+                </a:solidFill>
+                <a:latin typeface="Calibri"/>
+              </a:rPr>
+              <a:t>RECOMMENDATION</a:t>
+            </a:r>
+          </a:p>
+        </p:txBody>
+      </p:sp>
       <p:pic>
         <p:nvPicPr>
-          <p:cNvPr id="6" name="Picture 5" descr="orderflow.png"/>
+          <p:cNvPr id="9" name="Picture 8" descr="orderflow.png"/>
           <p:cNvPicPr>
             <a:picLocks noChangeAspect="1"/>
           </p:cNvPicPr>
@@ -13079,7 +14218,7 @@
       </p:pic>
       <p:sp>
         <p:nvSpPr>
-          <p:cNvPr id="7" name="Rounded Rectangle 6"/>
+          <p:cNvPr id="10" name="Rounded Rectangle 9"/>
           <p:cNvSpPr/>
           <p:nvPr/>
         </p:nvSpPr>
@@ -13131,7 +14270,7 @@
       </p:sp>
       <p:sp>
         <p:nvSpPr>
-          <p:cNvPr id="8" name="Rounded Rectangle 7"/>
+          <p:cNvPr id="11" name="Rounded Rectangle 10"/>
           <p:cNvSpPr/>
           <p:nvPr/>
         </p:nvSpPr>
@@ -13177,7 +14316,7 @@
       </p:sp>
       <p:sp>
         <p:nvSpPr>
-          <p:cNvPr id="9" name="TextBox 8"/>
+          <p:cNvPr id="12" name="TextBox 11"/>
           <p:cNvSpPr txBox="1"/>
           <p:nvPr/>
         </p:nvSpPr>
@@ -13222,7 +14361,7 @@
       </p:sp>
       <p:sp>
         <p:nvSpPr>
-          <p:cNvPr id="10" name="TextBox 9"/>
+          <p:cNvPr id="13" name="TextBox 12"/>
           <p:cNvSpPr txBox="1"/>
           <p:nvPr/>
         </p:nvSpPr>
@@ -13369,7 +14508,7 @@
       </p:sp>
       <p:sp>
         <p:nvSpPr>
-          <p:cNvPr id="11" name="Rounded Rectangle 10"/>
+          <p:cNvPr id="14" name="Rounded Rectangle 13"/>
           <p:cNvSpPr/>
           <p:nvPr/>
         </p:nvSpPr>
@@ -13421,7 +14560,7 @@
       </p:sp>
       <p:sp>
         <p:nvSpPr>
-          <p:cNvPr id="12" name="Rounded Rectangle 11"/>
+          <p:cNvPr id="15" name="Rounded Rectangle 14"/>
           <p:cNvSpPr/>
           <p:nvPr/>
         </p:nvSpPr>
@@ -13467,7 +14606,7 @@
       </p:sp>
       <p:sp>
         <p:nvSpPr>
-          <p:cNvPr id="13" name="TextBox 12"/>
+          <p:cNvPr id="16" name="TextBox 15"/>
           <p:cNvSpPr txBox="1"/>
           <p:nvPr/>
         </p:nvSpPr>
@@ -13512,7 +14651,7 @@
       </p:sp>
       <p:sp>
         <p:nvSpPr>
-          <p:cNvPr id="14" name="TextBox 13"/>
+          <p:cNvPr id="17" name="TextBox 16"/>
           <p:cNvSpPr txBox="1"/>
           <p:nvPr/>
         </p:nvSpPr>
@@ -13677,7 +14816,7 @@
       </p:sp>
       <p:sp>
         <p:nvSpPr>
-          <p:cNvPr id="15" name="TextBox 14"/>
+          <p:cNvPr id="18" name="TextBox 17"/>
           <p:cNvSpPr txBox="1"/>
           <p:nvPr/>
         </p:nvSpPr>
@@ -13722,7 +14861,7 @@
       </p:sp>
       <p:sp>
         <p:nvSpPr>
-          <p:cNvPr id="16" name="TextBox 15"/>
+          <p:cNvPr id="19" name="TextBox 18"/>
           <p:cNvSpPr txBox="1"/>
           <p:nvPr/>
         </p:nvSpPr>

</xml_diff>

<commit_message>
Milestone 1 deck: rewrite in plain language for a general audience
Simpler titles and bullets, jargon removed or explained; floor-plan and feasibility chart relabelled in everyday words. Co-Authored-By: Claude Opus 4.8 <noreply@anthropic.com>
</commit_message>
<xml_diff>
--- a/deliverables/DHL Group 3 Milestone 1 (v2).pptx
+++ b/deliverables/DHL Group 3 Milestone 1 (v2).pptx
@@ -3392,22 +3392,13 @@
               </a:spcAft>
             </a:pPr>
             <a:r>
-              <a:rPr sz="1400" b="0">
+              <a:rPr sz="1450" b="0">
                 <a:solidFill>
                   <a:srgbClr val="595959"/>
                 </a:solidFill>
                 <a:latin typeface="Calibri"/>
               </a:rPr>
-              <a:t>Deliverable 1 · Analysis &amp; Design Direction   ·   </a:t>
-            </a:r>
-            <a:r>
-              <a:rPr sz="1400" b="0">
-                <a:solidFill>
-                  <a:srgbClr val="595959"/>
-                </a:solidFill>
-                <a:latin typeface="Calibri"/>
-              </a:rPr>
-              <a:t>Assa Abloy operation, DHL Supply Chain Bemmel</a:t>
+              <a:t>A better layout for the Assa Abloy warehouse, run by DHL in Bemmel</a:t>
             </a:r>
           </a:p>
         </p:txBody>
@@ -3603,7 +3594,7 @@
                 </a:solidFill>
                 <a:latin typeface="Calibri"/>
               </a:rPr>
-              <a:t>SKU &amp; Inventory Profile</a:t>
+              <a:t>What's in the Warehouse</a:t>
             </a:r>
           </a:p>
         </p:txBody>
@@ -3648,7 +3639,7 @@
                 </a:solidFill>
                 <a:latin typeface="Calibri"/>
               </a:rPr>
-              <a:t>Warehouse profile — Assa Abloy operation, DHL Supply Chain Bemmel  |  Q2 2025</a:t>
+              <a:t>The products stored and how much stock is on site (3 months of 2025 data)</a:t>
             </a:r>
           </a:p>
         </p:txBody>
@@ -3973,7 +3964,7 @@
                 </a:solidFill>
                 <a:latin typeface="Calibri"/>
               </a:rPr>
-              <a:t>SKUs in stock</a:t>
+              <a:t>Different products</a:t>
             </a:r>
           </a:p>
         </p:txBody>
@@ -4117,7 +4108,7 @@
                 </a:solidFill>
                 <a:latin typeface="Calibri"/>
               </a:rPr>
-              <a:t>Peak pallet positions</a:t>
+              <a:t>Pallet spaces used (peak)</a:t>
             </a:r>
           </a:p>
         </p:txBody>
@@ -4261,7 +4252,7 @@
                 </a:solidFill>
                 <a:latin typeface="Calibri"/>
               </a:rPr>
-              <a:t>SKUs with 1 load</a:t>
+              <a:t>Products with 1 pallet</a:t>
             </a:r>
           </a:p>
         </p:txBody>
@@ -4405,7 +4396,7 @@
                 </a:solidFill>
                 <a:latin typeface="Calibri"/>
               </a:rPr>
-              <a:t>Loads &gt; 1 year old</a:t>
+              <a:t>Stock over 1 year old</a:t>
             </a:r>
           </a:p>
         </p:txBody>
@@ -4504,7 +4495,7 @@
                 </a:solidFill>
                 <a:latin typeface="Calibri"/>
               </a:rPr>
-              <a:t>78.3 h</a:t>
+              <a:t>~3 days</a:t>
             </a:r>
           </a:p>
         </p:txBody>
@@ -4549,7 +4540,7 @@
                 </a:solidFill>
                 <a:latin typeface="Calibri"/>
               </a:rPr>
-              <a:t>Average lead time</a:t>
+              <a:t>Order → shipped</a:t>
             </a:r>
           </a:p>
         </p:txBody>
@@ -4692,7 +4683,7 @@
                 </a:solidFill>
                 <a:latin typeface="Calibri"/>
               </a:rPr>
-              <a:t>Inventory &amp; storage</a:t>
+              <a:t>The products</a:t>
             </a:r>
           </a:p>
         </p:txBody>
@@ -4746,7 +4737,7 @@
                 </a:solidFill>
                 <a:latin typeface="Calibri"/>
               </a:rPr>
-              <a:t>5,291 SKUs</a:t>
+              <a:t>5,291 different products</a:t>
             </a:r>
             <a:r>
               <a:rPr sz="1250" b="0">
@@ -4755,7 +4746,7 @@
                 </a:solidFill>
                 <a:latin typeface="Calibri"/>
               </a:rPr>
-              <a:t> across 11 product families</a:t>
+              <a:t> in 11 groups (locks, cylinders, fittings…)</a:t>
             </a:r>
           </a:p>
           <a:p>
@@ -4780,31 +4771,22 @@
               <a:t>•  </a:t>
             </a:r>
             <a:r>
+              <a:rPr sz="1250" b="1">
+                <a:solidFill>
+                  <a:srgbClr val="262626"/>
+                </a:solidFill>
+                <a:latin typeface="Calibri"/>
+              </a:rPr>
+              <a:t>Most are small</a:t>
+            </a:r>
+            <a:r>
               <a:rPr sz="1250" b="0">
                 <a:solidFill>
                   <a:srgbClr val="262626"/>
                 </a:solidFill>
                 <a:latin typeface="Calibri"/>
               </a:rPr>
-              <a:t>3,115 have a case pack; </a:t>
-            </a:r>
-            <a:r>
-              <a:rPr sz="1250" b="1">
-                <a:solidFill>
-                  <a:srgbClr val="262626"/>
-                </a:solidFill>
-                <a:latin typeface="Calibri"/>
-              </a:rPr>
-              <a:t>2,176 (41%) are each-only</a:t>
-            </a:r>
-            <a:r>
-              <a:rPr sz="1250" b="0">
-                <a:solidFill>
-                  <a:srgbClr val="262626"/>
-                </a:solidFill>
-                <a:latin typeface="Calibri"/>
-              </a:rPr>
-              <a:t> → real each-pick demand</a:t>
+              <a:t> — a typical item is about the size of a coffee mug</a:t>
             </a:r>
           </a:p>
           <a:p>
@@ -4829,22 +4811,22 @@
               <a:t>•  </a:t>
             </a:r>
             <a:r>
+              <a:rPr sz="1250" b="1">
+                <a:solidFill>
+                  <a:srgbClr val="262626"/>
+                </a:solidFill>
+                <a:latin typeface="Calibri"/>
+              </a:rPr>
+              <a:t>2,176 (41%) are sold as single pieces</a:t>
+            </a:r>
+            <a:r>
               <a:rPr sz="1250" b="0">
                 <a:solidFill>
                   <a:srgbClr val="262626"/>
                 </a:solidFill>
                 <a:latin typeface="Calibri"/>
               </a:rPr>
-              <a:t>Small items: </a:t>
-            </a:r>
-            <a:r>
-              <a:rPr sz="1250" b="1">
-                <a:solidFill>
-                  <a:srgbClr val="262626"/>
-                </a:solidFill>
-                <a:latin typeface="Calibri"/>
-              </a:rPr>
-              <a:t>median volume 0.0005 m³ (~500 cm³)</a:t>
+              <a:t>, not full boxes</a:t>
             </a:r>
           </a:p>
           <a:p>
@@ -4875,7 +4857,7 @@
                 </a:solidFill>
                 <a:latin typeface="Calibri"/>
               </a:rPr>
-              <a:t>Median 1,000 units/pallet</a:t>
+              <a:t>A full pallet holds ~1,000 pieces</a:t>
             </a:r>
             <a:r>
               <a:rPr sz="1250" b="0">
@@ -4884,16 +4866,7 @@
                 </a:solidFill>
                 <a:latin typeface="Calibri"/>
               </a:rPr>
-              <a:t>; median pallet weight </a:t>
-            </a:r>
-            <a:r>
-              <a:rPr sz="1250" b="1">
-                <a:solidFill>
-                  <a:srgbClr val="262626"/>
-                </a:solidFill>
-                <a:latin typeface="Calibri"/>
-              </a:rPr>
-              <a:t>431 kg</a:t>
+              <a:t> and weighs ~431 kg on average</a:t>
             </a:r>
           </a:p>
           <a:p>
@@ -4918,71 +4891,22 @@
               <a:t>•  </a:t>
             </a:r>
             <a:r>
+              <a:rPr sz="1250" b="1">
+                <a:solidFill>
+                  <a:srgbClr val="262626"/>
+                </a:solidFill>
+                <a:latin typeface="Calibri"/>
+              </a:rPr>
+              <a:t>138 products are hazardous</a:t>
+            </a:r>
+            <a:r>
               <a:rPr sz="1250" b="0">
                 <a:solidFill>
                   <a:srgbClr val="262626"/>
                 </a:solidFill>
                 <a:latin typeface="Calibri"/>
               </a:rPr>
-              <a:t>Pallet types: </a:t>
-            </a:r>
-            <a:r>
-              <a:rPr sz="1250" b="1">
-                <a:solidFill>
-                  <a:srgbClr val="262626"/>
-                </a:solidFill>
-                <a:latin typeface="Calibri"/>
-              </a:rPr>
-              <a:t>EURO 2,864, K3 2,040, XLONG 168</a:t>
-            </a:r>
-            <a:r>
-              <a:rPr sz="1250" b="0">
-                <a:solidFill>
-                  <a:srgbClr val="262626"/>
-                </a:solidFill>
-                <a:latin typeface="Calibri"/>
-              </a:rPr>
-              <a:t> (+K1/K2/K5/CONS)</a:t>
-            </a:r>
-          </a:p>
-          <a:p>
-            <a:pPr algn="l">
-              <a:lnSpc>
-                <a:spcPct val="103000"/>
-              </a:lnSpc>
-              <a:spcBef>
-                <a:spcPts val="0"/>
-              </a:spcBef>
-              <a:spcAft>
-                <a:spcPts val="700"/>
-              </a:spcAft>
-            </a:pPr>
-            <a:r>
-              <a:rPr sz="1250" b="0">
-                <a:solidFill>
-                  <a:srgbClr val="6B7280"/>
-                </a:solidFill>
-                <a:latin typeface="Calibri"/>
-              </a:rPr>
-              <a:t>•  </a:t>
-            </a:r>
-            <a:r>
-              <a:rPr sz="1250" b="1">
-                <a:solidFill>
-                  <a:srgbClr val="262626"/>
-                </a:solidFill>
-                <a:latin typeface="Calibri"/>
-              </a:rPr>
-              <a:t>138 hazardous SKUs</a:t>
-            </a:r>
-            <a:r>
-              <a:rPr sz="1250" b="0">
-                <a:solidFill>
-                  <a:srgbClr val="262626"/>
-                </a:solidFill>
-                <a:latin typeface="Calibri"/>
-              </a:rPr>
-              <a:t> need segregation</a:t>
+              <a:t> and must be kept apart</a:t>
             </a:r>
           </a:p>
         </p:txBody>
@@ -5125,7 +5049,7 @@
                 </a:solidFill>
                 <a:latin typeface="Calibri"/>
               </a:rPr>
-              <a:t>Storage-position requirement</a:t>
+              <a:t>The stock</a:t>
             </a:r>
           </a:p>
         </p:txBody>
@@ -5173,31 +5097,22 @@
               <a:t>•  </a:t>
             </a:r>
             <a:r>
+              <a:rPr sz="1250" b="1">
+                <a:solidFill>
+                  <a:srgbClr val="262626"/>
+                </a:solidFill>
+                <a:latin typeface="Calibri"/>
+              </a:rPr>
+              <a:t>At the busiest moment, ~8,500 pallet spaces were in use</a:t>
+            </a:r>
+            <a:r>
               <a:rPr sz="1250" b="0">
                 <a:solidFill>
                   <a:srgbClr val="262626"/>
                 </a:solidFill>
                 <a:latin typeface="Calibri"/>
               </a:rPr>
-              <a:t>Occupied locations grew </a:t>
-            </a:r>
-            <a:r>
-              <a:rPr sz="1250" b="1">
-                <a:solidFill>
-                  <a:srgbClr val="262626"/>
-                </a:solidFill>
-                <a:latin typeface="Calibri"/>
-              </a:rPr>
-              <a:t>7,715 → 8,512</a:t>
-            </a:r>
-            <a:r>
-              <a:rPr sz="1250" b="0">
-                <a:solidFill>
-                  <a:srgbClr val="262626"/>
-                </a:solidFill>
-                <a:latin typeface="Calibri"/>
-              </a:rPr>
-              <a:t> (Apr→Jun); cube +15%</a:t>
+              <a:t> — this is our real storage need</a:t>
             </a:r>
           </a:p>
           <a:p>
@@ -5222,22 +5137,13 @@
               <a:t>•  </a:t>
             </a:r>
             <a:r>
-              <a:rPr sz="1250" b="1">
+              <a:rPr sz="1250" b="0">
                 <a:solidFill>
                   <a:srgbClr val="262626"/>
                 </a:solidFill>
                 <a:latin typeface="Calibri"/>
               </a:rPr>
-              <a:t>Peak pallet positions ≈ 8,512</a:t>
-            </a:r>
-            <a:r>
-              <a:rPr sz="1250" b="0">
-                <a:solidFill>
-                  <a:srgbClr val="262626"/>
-                </a:solidFill>
-                <a:latin typeface="Calibri"/>
-              </a:rPr>
-              <a:t> — the storage baseline (not the 11,015 loads)</a:t>
+              <a:t>(~11,000 pallets fit in those spaces — some spaces hold two)</a:t>
             </a:r>
           </a:p>
           <a:p>
@@ -5268,7 +5174,7 @@
                 </a:solidFill>
                 <a:latin typeface="Calibri"/>
               </a:rPr>
-              <a:t>72.7% of SKUs occupy a single load</a:t>
+              <a:t>Stock is growing: pallet spaces rose ~8% in 3 months</a:t>
             </a:r>
             <a:r>
               <a:rPr sz="1250" b="0">
@@ -5277,7 +5183,7 @@
                 </a:solidFill>
                 <a:latin typeface="Calibri"/>
               </a:rPr>
-              <a:t>; median 1 load/SKU</a:t>
+              <a:t> — we must leave room to grow</a:t>
             </a:r>
           </a:p>
           <a:p>
@@ -5302,22 +5208,22 @@
               <a:t>•  </a:t>
             </a:r>
             <a:r>
+              <a:rPr sz="1250" b="1">
+                <a:solidFill>
+                  <a:srgbClr val="262626"/>
+                </a:solidFill>
+                <a:latin typeface="Calibri"/>
+              </a:rPr>
+              <a:t>73% of products need only one pallet</a:t>
+            </a:r>
+            <a:r>
               <a:rPr sz="1250" b="0">
                 <a:solidFill>
                   <a:srgbClr val="262626"/>
                 </a:solidFill>
                 <a:latin typeface="Calibri"/>
               </a:rPr>
-              <a:t>Stock flat ~2.9M units while loads rose → </a:t>
-            </a:r>
-            <a:r>
-              <a:rPr sz="1250" b="1">
-                <a:solidFill>
-                  <a:srgbClr val="262626"/>
-                </a:solidFill>
-                <a:latin typeface="Calibri"/>
-              </a:rPr>
-              <a:t>some positions under-utilised</a:t>
+              <a:t> — lots of slow sellers</a:t>
             </a:r>
           </a:p>
           <a:p>
@@ -5342,22 +5248,22 @@
               <a:t>•  </a:t>
             </a:r>
             <a:r>
+              <a:rPr sz="1250" b="0">
+                <a:solidFill>
+                  <a:srgbClr val="262626"/>
+                </a:solidFill>
+                <a:latin typeface="Calibri"/>
+              </a:rPr>
+              <a:t>Same stock spread over more spaces → </a:t>
+            </a:r>
+            <a:r>
               <a:rPr sz="1250" b="1">
                 <a:solidFill>
                   <a:srgbClr val="262626"/>
                 </a:solidFill>
                 <a:latin typeface="Calibri"/>
               </a:rPr>
-              <a:t>11,015 loads across 8,512 locations</a:t>
-            </a:r>
-            <a:r>
-              <a:rPr sz="1250" b="0">
-                <a:solidFill>
-                  <a:srgbClr val="262626"/>
-                </a:solidFill>
-                <a:latin typeface="Calibri"/>
-              </a:rPr>
-              <a:t> → some already hold &gt;1 load</a:t>
+              <a:t>space is being wasted today</a:t>
             </a:r>
           </a:p>
         </p:txBody>
@@ -5554,7 +5460,7 @@
                 </a:solidFill>
                 <a:latin typeface="Calibri"/>
               </a:rPr>
-              <a:t>Order &amp; Picking Profile</a:t>
+              <a:t>What the Orders Look Like</a:t>
             </a:r>
           </a:p>
         </p:txBody>
@@ -5599,7 +5505,7 @@
                 </a:solidFill>
                 <a:latin typeface="Calibri"/>
               </a:rPr>
-              <a:t>Pick method chosen from the client's orders — not past DHL practice</a:t>
+              <a:t>How customers order tells us the best way to pick — not how DHL did it before</a:t>
             </a:r>
           </a:p>
         </p:txBody>
@@ -5924,7 +5830,7 @@
                 </a:solidFill>
                 <a:latin typeface="Calibri"/>
               </a:rPr>
-              <a:t>Orders (Q2)</a:t>
+              <a:t>Orders (3 months)</a:t>
             </a:r>
           </a:p>
         </p:txBody>
@@ -6212,7 +6118,7 @@
                 </a:solidFill>
                 <a:latin typeface="Calibri"/>
               </a:rPr>
-              <a:t>Single-line orders</a:t>
+              <a:t>Orders for 1 product</a:t>
             </a:r>
           </a:p>
         </p:txBody>
@@ -6356,7 +6262,7 @@
                 </a:solidFill>
                 <a:latin typeface="Calibri"/>
               </a:rPr>
-              <a:t>Median units / line</a:t>
+              <a:t>Pieces in a typical line</a:t>
             </a:r>
           </a:p>
         </p:txBody>
@@ -6499,7 +6405,7 @@
                 </a:solidFill>
                 <a:latin typeface="Calibri"/>
               </a:rPr>
-              <a:t>What the orders look like</a:t>
+              <a:t>How customers order</a:t>
             </a:r>
           </a:p>
         </p:txBody>
@@ -6553,7 +6459,7 @@
                 </a:solidFill>
                 <a:latin typeface="Calibri"/>
               </a:rPr>
-              <a:t>8,781 orders · 39,069 lines</a:t>
+              <a:t>One "line" = one product on an order</a:t>
             </a:r>
             <a:r>
               <a:rPr sz="1250" b="0">
@@ -6562,7 +6468,7 @@
                 </a:solidFill>
                 <a:latin typeface="Calibri"/>
               </a:rPr>
-              <a:t> over the quarter</a:t>
+              <a:t> (39,069 lines in total)</a:t>
             </a:r>
           </a:p>
           <a:p>
@@ -6593,34 +6499,7 @@
                 </a:solidFill>
                 <a:latin typeface="Calibri"/>
               </a:rPr>
-              <a:t>50.5% single-line orders</a:t>
-            </a:r>
-            <a:r>
-              <a:rPr sz="1250" b="0">
-                <a:solidFill>
-                  <a:srgbClr val="262626"/>
-                </a:solidFill>
-                <a:latin typeface="Calibri"/>
-              </a:rPr>
-              <a:t>; </a:t>
-            </a:r>
-            <a:r>
-              <a:rPr sz="1250" b="1">
-                <a:solidFill>
-                  <a:srgbClr val="262626"/>
-                </a:solidFill>
-                <a:latin typeface="Calibri"/>
-              </a:rPr>
-              <a:t>23.6% single-unit lines</a:t>
-            </a:r>
-            <a:r>
-              <a:rPr sz="1250" b="0">
-                <a:solidFill>
-                  <a:srgbClr val="262626"/>
-                </a:solidFill>
-                <a:latin typeface="Calibri"/>
-              </a:rPr>
-              <a:t> → small-order-heavy</a:t>
+              <a:t>Half of all orders (50.5%) are for a single product</a:t>
             </a:r>
           </a:p>
           <a:p>
@@ -6651,7 +6530,7 @@
                 </a:solidFill>
                 <a:latin typeface="Calibri"/>
               </a:rPr>
-              <a:t>Lines/order: median 1, mean 4.45</a:t>
+              <a:t>Orders are small</a:t>
             </a:r>
             <a:r>
               <a:rPr sz="1250" b="0">
@@ -6660,7 +6539,7 @@
                 </a:solidFill>
                 <a:latin typeface="Calibri"/>
               </a:rPr>
-              <a:t>; units/line: median 5</a:t>
+              <a:t> — a typical line is ~5 pieces, far below a full pallet (~1,000)</a:t>
             </a:r>
           </a:p>
           <a:p>
@@ -6685,71 +6564,22 @@
               <a:t>•  </a:t>
             </a:r>
             <a:r>
+              <a:rPr sz="1250" b="1">
+                <a:solidFill>
+                  <a:srgbClr val="262626"/>
+                </a:solidFill>
+                <a:latin typeface="Calibri"/>
+              </a:rPr>
+              <a:t>Customers across NL, Belgium, Germany, France</a:t>
+            </a:r>
+            <a:r>
               <a:rPr sz="1250" b="0">
                 <a:solidFill>
                   <a:srgbClr val="262626"/>
                 </a:solidFill>
                 <a:latin typeface="Calibri"/>
               </a:rPr>
-              <a:t>Lines are small: </a:t>
-            </a:r>
-            <a:r>
-              <a:rPr sz="1250" b="1">
-                <a:solidFill>
-                  <a:srgbClr val="262626"/>
-                </a:solidFill>
-                <a:latin typeface="Calibri"/>
-              </a:rPr>
-              <a:t>median 5 units/line vs ~1,000/pallet</a:t>
-            </a:r>
-            <a:r>
-              <a:rPr sz="1250" b="0">
-                <a:solidFill>
-                  <a:srgbClr val="262626"/>
-                </a:solidFill>
-                <a:latin typeface="Calibri"/>
-              </a:rPr>
-              <a:t> → case &amp; piece, not pallet</a:t>
-            </a:r>
-          </a:p>
-          <a:p>
-            <a:pPr algn="l">
-              <a:lnSpc>
-                <a:spcPct val="103000"/>
-              </a:lnSpc>
-              <a:spcBef>
-                <a:spcPts val="0"/>
-              </a:spcBef>
-              <a:spcAft>
-                <a:spcPts val="700"/>
-              </a:spcAft>
-            </a:pPr>
-            <a:r>
-              <a:rPr sz="1250" b="0">
-                <a:solidFill>
-                  <a:srgbClr val="6B7280"/>
-                </a:solidFill>
-                <a:latin typeface="Calibri"/>
-              </a:rPr>
-              <a:t>•  </a:t>
-            </a:r>
-            <a:r>
-              <a:rPr sz="1250" b="0">
-                <a:solidFill>
-                  <a:srgbClr val="262626"/>
-                </a:solidFill>
-                <a:latin typeface="Calibri"/>
-              </a:rPr>
-              <a:t>Channels NLD/EDC/BEL/DIRECT/AMADE — </a:t>
-            </a:r>
-            <a:r>
-              <a:rPr sz="1250" b="1">
-                <a:solidFill>
-                  <a:srgbClr val="262626"/>
-                </a:solidFill>
-                <a:latin typeface="Calibri"/>
-              </a:rPr>
-              <a:t>an NL hub serving W-Europe</a:t>
+              <a:t> — an NL hub for Western Europe</a:t>
             </a:r>
           </a:p>
         </p:txBody>
@@ -6892,7 +6722,7 @@
                 </a:solidFill>
                 <a:latin typeface="Calibri"/>
               </a:rPr>
-              <a:t>Pick method derived from demand</a:t>
+              <a:t>So how should we pick?</a:t>
             </a:r>
           </a:p>
         </p:txBody>
@@ -6946,7 +6776,7 @@
                 </a:solidFill>
                 <a:latin typeface="Calibri"/>
               </a:rPr>
-              <a:t>Many small / single-line orders → </a:t>
+              <a:t>Lots of small orders → </a:t>
             </a:r>
             <a:r>
               <a:rPr sz="1250" b="1">
@@ -6955,16 +6785,7 @@
                 </a:solidFill>
                 <a:latin typeface="Calibri"/>
               </a:rPr>
-              <a:t>zone + batch/wave picking</a:t>
-            </a:r>
-            <a:r>
-              <a:rPr sz="1250" b="0">
-                <a:solidFill>
-                  <a:srgbClr val="262626"/>
-                </a:solidFill>
-                <a:latin typeface="Calibri"/>
-              </a:rPr>
-              <a:t> (biggest labour lever)</a:t>
+              <a:t>let pickers collect several orders in one trip</a:t>
             </a:r>
           </a:p>
           <a:p>
@@ -6995,7 +6816,7 @@
                 </a:solidFill>
                 <a:latin typeface="Calibri"/>
               </a:rPr>
-              <a:t>Real each demand (41% each-only, median 5 u/line) → </a:t>
+              <a:t>Many single pieces → </a:t>
             </a:r>
             <a:r>
               <a:rPr sz="1250" b="1">
@@ -7004,16 +6825,7 @@
                 </a:solidFill>
                 <a:latin typeface="Calibri"/>
               </a:rPr>
-              <a:t>forward-pick module</a:t>
-            </a:r>
-            <a:r>
-              <a:rPr sz="1250" b="0">
-                <a:solidFill>
-                  <a:srgbClr val="262626"/>
-                </a:solidFill>
-                <a:latin typeface="Calibri"/>
-              </a:rPr>
-              <a:t> for fast case/each</a:t>
+              <a:t>keep best-sellers in a small, easy-to-reach picking area</a:t>
             </a:r>
           </a:p>
           <a:p>
@@ -7044,16 +6856,7 @@
                 </a:solidFill>
                 <a:latin typeface="Calibri"/>
               </a:rPr>
-              <a:t>Full-pallet only where line qty ≈ pallet qty</a:t>
-            </a:r>
-            <a:r>
-              <a:rPr sz="1250" b="0">
-                <a:solidFill>
-                  <a:srgbClr val="262626"/>
-                </a:solidFill>
-                <a:latin typeface="Calibri"/>
-              </a:rPr>
-              <a:t> (rare)</a:t>
+              <a:t>Full-pallet picking is rarely needed</a:t>
             </a:r>
           </a:p>
           <a:p>
@@ -7078,31 +6881,22 @@
               <a:t>•  </a:t>
             </a:r>
             <a:r>
+              <a:rPr sz="1250" b="1">
+                <a:solidFill>
+                  <a:srgbClr val="262626"/>
+                </a:solidFill>
+                <a:latin typeface="Calibri"/>
+              </a:rPr>
+              <a:t>We base this on the orders themselves</a:t>
+            </a:r>
+            <a:r>
               <a:rPr sz="1250" b="0">
                 <a:solidFill>
                   <a:srgbClr val="262626"/>
                 </a:solidFill>
                 <a:latin typeface="Calibri"/>
               </a:rPr>
-              <a:t>Decided from </a:t>
-            </a:r>
-            <a:r>
-              <a:rPr sz="1250" b="1">
-                <a:solidFill>
-                  <a:srgbClr val="262626"/>
-                </a:solidFill>
-                <a:latin typeface="Calibri"/>
-              </a:rPr>
-              <a:t>order composition, not WMS pick-type flags</a:t>
-            </a:r>
-            <a:r>
-              <a:rPr sz="1250" b="0">
-                <a:solidFill>
-                  <a:srgbClr val="262626"/>
-                </a:solidFill>
-                <a:latin typeface="Calibri"/>
-              </a:rPr>
-              <a:t> — so the 20% unlabelled 'Other' does not drive the design</a:t>
+              <a:t>, not on how DHL happened to do it before — so the 20% of unlabelled picks don't affect our design</a:t>
             </a:r>
           </a:p>
         </p:txBody>
@@ -7299,7 +7093,7 @@
                 </a:solidFill>
                 <a:latin typeface="Calibri"/>
               </a:rPr>
-              <a:t>Demand-Based ABC Classification</a:t>
+              <a:t>Which Products Sell the Most</a:t>
             </a:r>
           </a:p>
         </p:txBody>
@@ -7344,7 +7138,7 @@
                 </a:solidFill>
                 <a:latin typeface="Calibri"/>
               </a:rPr>
-              <a:t>Prioritising SKUs by actual outbound demand</a:t>
+              <a:t>We ranked every product by how often it's actually ordered</a:t>
             </a:r>
           </a:p>
         </p:txBody>
@@ -7546,8 +7340,8 @@
         </p:blipFill>
         <p:spPr>
           <a:xfrm>
-            <a:off x="609487" y="1783080"/>
-            <a:ext cx="5593304" cy="4297680"/>
+            <a:off x="728494" y="1783080"/>
+            <a:ext cx="5355291" cy="4114800"/>
           </a:xfrm>
           <a:prstGeom prst="rect">
             <a:avLst/>
@@ -7563,7 +7357,7 @@
         <p:spPr>
           <a:xfrm>
             <a:off x="6720840" y="1783080"/>
-            <a:ext cx="4892040" cy="1965960"/>
+            <a:ext cx="4892040" cy="2148840"/>
           </a:xfrm>
           <a:prstGeom prst="roundRect">
             <a:avLst>
@@ -7615,7 +7409,7 @@
         <p:spPr>
           <a:xfrm>
             <a:off x="6702552" y="1892807"/>
-            <a:ext cx="118872" cy="1746504"/>
+            <a:ext cx="118872" cy="1929384"/>
           </a:xfrm>
           <a:prstGeom prst="roundRect">
             <a:avLst>
@@ -7692,7 +7486,7 @@
                 </a:solidFill>
                 <a:latin typeface="Calibri"/>
               </a:rPr>
-              <a:t>ABC split (by demand)</a:t>
+              <a:t>The 80/20 rule — even stronger</a:t>
             </a:r>
           </a:p>
         </p:txBody>
@@ -7706,7 +7500,7 @@
         <p:spPr>
           <a:xfrm>
             <a:off x="6995159" y="2386584"/>
-            <a:ext cx="4389120" cy="1234439"/>
+            <a:ext cx="4389120" cy="1417320"/>
           </a:xfrm>
           <a:prstGeom prst="rect">
             <a:avLst/>
@@ -7746,7 +7540,7 @@
                 </a:solidFill>
                 <a:latin typeface="Calibri"/>
               </a:rPr>
-              <a:t>A — 13.0% of SKUs → </a:t>
+              <a:t>A — the stars: 13% of products = </a:t>
             </a:r>
             <a:r>
               <a:rPr sz="1300" b="1">
@@ -7755,7 +7549,7 @@
                 </a:solidFill>
                 <a:latin typeface="Calibri"/>
               </a:rPr>
-              <a:t>80.0% of demand</a:t>
+              <a:t>80% of what ships</a:t>
             </a:r>
           </a:p>
           <a:p>
@@ -7786,7 +7580,7 @@
                 </a:solidFill>
                 <a:latin typeface="Calibri"/>
               </a:rPr>
-              <a:t>B — 19.7% of SKUs → </a:t>
+              <a:t>B — steady: 20% of products = </a:t>
             </a:r>
             <a:r>
               <a:rPr sz="1300" b="1">
@@ -7795,7 +7589,7 @@
                 </a:solidFill>
                 <a:latin typeface="Calibri"/>
               </a:rPr>
-              <a:t>15.0% of demand</a:t>
+              <a:t>15%</a:t>
             </a:r>
           </a:p>
           <a:p>
@@ -7826,7 +7620,7 @@
                 </a:solidFill>
                 <a:latin typeface="Calibri"/>
               </a:rPr>
-              <a:t>C — 67.3% of SKUs → </a:t>
+              <a:t>C — slow: 67% of products = </a:t>
             </a:r>
             <a:r>
               <a:rPr sz="1300" b="1">
@@ -7835,7 +7629,7 @@
                 </a:solidFill>
                 <a:latin typeface="Calibri"/>
               </a:rPr>
-              <a:t>5.0% of demand</a:t>
+              <a:t>only 5%</a:t>
             </a:r>
           </a:p>
         </p:txBody>
@@ -7856,8 +7650,8 @@
         </p:blipFill>
         <p:spPr>
           <a:xfrm>
-            <a:off x="7479663" y="3886200"/>
-            <a:ext cx="3374393" cy="2148840"/>
+            <a:off x="7623254" y="4069080"/>
+            <a:ext cx="3087210" cy="1965960"/>
           </a:xfrm>
           <a:prstGeom prst="rect">
             <a:avLst/>
@@ -7872,7 +7666,7 @@
         </p:nvSpPr>
         <p:spPr>
           <a:xfrm>
-            <a:off x="502920" y="6172200"/>
+            <a:off x="502920" y="6080760"/>
             <a:ext cx="11155680" cy="457200"/>
           </a:xfrm>
           <a:prstGeom prst="rect">
@@ -7904,7 +7698,7 @@
                 </a:solidFill>
                 <a:latin typeface="Calibri"/>
               </a:rPr>
-              <a:t>Only 48.6% of SKUs agree with the current WMS class</a:t>
+              <a:t>Today only about half the products are stored by how often they sell</a:t>
             </a:r>
             <a:r>
               <a:rPr sz="1250" b="0">
@@ -7913,7 +7707,7 @@
                 </a:solidFill>
                 <a:latin typeface="Calibri"/>
               </a:rPr>
-              <a:t> → fast movers still sit far from dispatch; re-slot to demand.</a:t>
+              <a:t> — so many best-sellers sit far from the door. They should move closer.</a:t>
             </a:r>
           </a:p>
         </p:txBody>
@@ -8110,113 +7904,21 @@
                 </a:solidFill>
                 <a:latin typeface="Calibri"/>
               </a:rPr>
-              <a:t>Peak Demand Analysis</a:t>
-            </a:r>
-          </a:p>
-        </p:txBody>
-      </p:sp>
-      <p:sp>
-        <p:nvSpPr>
-          <p:cNvPr id="4" name="Rounded Rectangle 3"/>
-          <p:cNvSpPr/>
-          <p:nvPr/>
-        </p:nvSpPr>
-        <p:spPr>
-          <a:xfrm>
-            <a:off x="10411358" y="329184"/>
-            <a:ext cx="1219809" cy="329184"/>
-          </a:xfrm>
-          <a:prstGeom prst="roundRect">
-            <a:avLst>
-              <a:gd name="adj" fmla="val 50000"/>
-            </a:avLst>
-          </a:prstGeom>
-          <a:solidFill>
-            <a:srgbClr val="F3F4F6"/>
-          </a:solidFill>
-          <a:ln>
-            <a:noFill/>
-          </a:ln>
-          <a:effectLst/>
-        </p:spPr>
-        <p:style>
-          <a:lnRef idx="1">
-            <a:schemeClr val="accent1"/>
-          </a:lnRef>
-          <a:fillRef idx="3">
-            <a:schemeClr val="accent1"/>
-          </a:fillRef>
-          <a:effectRef idx="2">
-            <a:schemeClr val="accent1"/>
-          </a:effectRef>
-          <a:fontRef idx="minor">
-            <a:schemeClr val="lt1"/>
-          </a:fontRef>
-        </p:style>
-        <p:txBody>
-          <a:bodyPr rtlCol="0" anchor="ctr"/>
-          <a:lstStyle/>
-          <a:p>
-            <a:pPr algn="ctr"/>
-          </a:p>
-        </p:txBody>
-      </p:sp>
-      <p:sp>
-        <p:nvSpPr>
-          <p:cNvPr id="5" name="Rounded Rectangle 4"/>
-          <p:cNvSpPr/>
-          <p:nvPr/>
-        </p:nvSpPr>
-        <p:spPr>
-          <a:xfrm>
-            <a:off x="10539374" y="457200"/>
-            <a:ext cx="82296" cy="82296"/>
-          </a:xfrm>
-          <a:prstGeom prst="roundRect">
-            <a:avLst>
-              <a:gd name="adj" fmla="val 50000"/>
-            </a:avLst>
-          </a:prstGeom>
-          <a:solidFill>
-            <a:srgbClr val="FFCC00"/>
-          </a:solidFill>
-          <a:ln>
-            <a:noFill/>
-          </a:ln>
-          <a:effectLst/>
-        </p:spPr>
-        <p:style>
-          <a:lnRef idx="1">
-            <a:schemeClr val="accent1"/>
-          </a:lnRef>
-          <a:fillRef idx="3">
-            <a:schemeClr val="accent1"/>
-          </a:fillRef>
-          <a:effectRef idx="2">
-            <a:schemeClr val="accent1"/>
-          </a:effectRef>
-          <a:fontRef idx="minor">
-            <a:schemeClr val="lt1"/>
-          </a:fontRef>
-        </p:style>
-        <p:txBody>
-          <a:bodyPr rtlCol="0" anchor="ctr"/>
-          <a:lstStyle/>
-          <a:p>
-            <a:pPr algn="ctr"/>
-          </a:p>
-        </p:txBody>
-      </p:sp>
-      <p:sp>
-        <p:nvSpPr>
-          <p:cNvPr id="6" name="TextBox 5"/>
+              <a:t>Busy Days vs Normal Days</a:t>
+            </a:r>
+          </a:p>
+        </p:txBody>
+      </p:sp>
+      <p:sp>
+        <p:nvSpPr>
+          <p:cNvPr id="4" name="TextBox 3"/>
           <p:cNvSpPr txBox="1"/>
           <p:nvPr/>
         </p:nvSpPr>
         <p:spPr>
           <a:xfrm>
-            <a:off x="10667390" y="329184"/>
-            <a:ext cx="927201" cy="329184"/>
+            <a:off x="603504" y="1078992"/>
+            <a:ext cx="10058400" cy="365760"/>
           </a:xfrm>
           <a:prstGeom prst="rect">
             <a:avLst/>
@@ -8224,7 +7926,7 @@
           <a:noFill/>
         </p:spPr>
         <p:txBody>
-          <a:bodyPr wrap="square" anchor="ctr" lIns="54864" rIns="54864" tIns="18288" bIns="18288">
+          <a:bodyPr wrap="square" anchor="t" lIns="54864" rIns="54864" tIns="18288" bIns="18288">
             <a:spAutoFit/>
           </a:bodyPr>
           <a:lstStyle/>
@@ -8241,35 +7943,171 @@
               </a:spcAft>
             </a:pPr>
             <a:r>
-              <a:rPr sz="1050" b="1">
-                <a:solidFill>
-                  <a:srgbClr val="D40511"/>
-                </a:solidFill>
-                <a:latin typeface="Calibri"/>
-              </a:rPr>
-              <a:t>ANALYSIS</a:t>
-            </a:r>
-          </a:p>
-        </p:txBody>
-      </p:sp>
-      <p:sp>
-        <p:nvSpPr>
-          <p:cNvPr id="7" name="TextBox 6"/>
-          <p:cNvSpPr txBox="1"/>
-          <p:nvPr/>
-        </p:nvSpPr>
-        <p:spPr>
-          <a:xfrm>
-            <a:off x="566928" y="1234440"/>
-            <a:ext cx="5029200" cy="320040"/>
+              <a:rPr sz="1350" b="0">
+                <a:solidFill>
+                  <a:srgbClr val="595959"/>
+                </a:solidFill>
+                <a:latin typeface="Calibri"/>
+              </a:rPr>
+              <a:t>The warehouse must cope with the busiest days, not just the average</a:t>
+            </a:r>
+          </a:p>
+        </p:txBody>
+      </p:sp>
+      <p:sp>
+        <p:nvSpPr>
+          <p:cNvPr id="5" name="Rectangle 4"/>
+          <p:cNvSpPr/>
+          <p:nvPr/>
+        </p:nvSpPr>
+        <p:spPr>
+          <a:xfrm>
+            <a:off x="603504" y="1481328"/>
+            <a:ext cx="1234440" cy="50292"/>
           </a:xfrm>
           <a:prstGeom prst="rect">
             <a:avLst/>
           </a:prstGeom>
+          <a:solidFill>
+            <a:srgbClr val="D40511"/>
+          </a:solidFill>
+          <a:ln>
+            <a:noFill/>
+          </a:ln>
+          <a:effectLst/>
+        </p:spPr>
+        <p:style>
+          <a:lnRef idx="1">
+            <a:schemeClr val="accent1"/>
+          </a:lnRef>
+          <a:fillRef idx="3">
+            <a:schemeClr val="accent1"/>
+          </a:fillRef>
+          <a:effectRef idx="2">
+            <a:schemeClr val="accent1"/>
+          </a:effectRef>
+          <a:fontRef idx="minor">
+            <a:schemeClr val="lt1"/>
+          </a:fontRef>
+        </p:style>
+        <p:txBody>
+          <a:bodyPr rtlCol="0" anchor="ctr"/>
+          <a:lstStyle/>
+          <a:p>
+            <a:pPr algn="ctr"/>
+          </a:p>
+        </p:txBody>
+      </p:sp>
+      <p:sp>
+        <p:nvSpPr>
+          <p:cNvPr id="6" name="Rounded Rectangle 5"/>
+          <p:cNvSpPr/>
+          <p:nvPr/>
+        </p:nvSpPr>
+        <p:spPr>
+          <a:xfrm>
+            <a:off x="10411358" y="329184"/>
+            <a:ext cx="1219809" cy="329184"/>
+          </a:xfrm>
+          <a:prstGeom prst="roundRect">
+            <a:avLst>
+              <a:gd name="adj" fmla="val 50000"/>
+            </a:avLst>
+          </a:prstGeom>
+          <a:solidFill>
+            <a:srgbClr val="F3F4F6"/>
+          </a:solidFill>
+          <a:ln>
+            <a:noFill/>
+          </a:ln>
+          <a:effectLst/>
+        </p:spPr>
+        <p:style>
+          <a:lnRef idx="1">
+            <a:schemeClr val="accent1"/>
+          </a:lnRef>
+          <a:fillRef idx="3">
+            <a:schemeClr val="accent1"/>
+          </a:fillRef>
+          <a:effectRef idx="2">
+            <a:schemeClr val="accent1"/>
+          </a:effectRef>
+          <a:fontRef idx="minor">
+            <a:schemeClr val="lt1"/>
+          </a:fontRef>
+        </p:style>
+        <p:txBody>
+          <a:bodyPr rtlCol="0" anchor="ctr"/>
+          <a:lstStyle/>
+          <a:p>
+            <a:pPr algn="ctr"/>
+          </a:p>
+        </p:txBody>
+      </p:sp>
+      <p:sp>
+        <p:nvSpPr>
+          <p:cNvPr id="7" name="Rounded Rectangle 6"/>
+          <p:cNvSpPr/>
+          <p:nvPr/>
+        </p:nvSpPr>
+        <p:spPr>
+          <a:xfrm>
+            <a:off x="10539374" y="457200"/>
+            <a:ext cx="82296" cy="82296"/>
+          </a:xfrm>
+          <a:prstGeom prst="roundRect">
+            <a:avLst>
+              <a:gd name="adj" fmla="val 50000"/>
+            </a:avLst>
+          </a:prstGeom>
+          <a:solidFill>
+            <a:srgbClr val="FFCC00"/>
+          </a:solidFill>
+          <a:ln>
+            <a:noFill/>
+          </a:ln>
+          <a:effectLst/>
+        </p:spPr>
+        <p:style>
+          <a:lnRef idx="1">
+            <a:schemeClr val="accent1"/>
+          </a:lnRef>
+          <a:fillRef idx="3">
+            <a:schemeClr val="accent1"/>
+          </a:fillRef>
+          <a:effectRef idx="2">
+            <a:schemeClr val="accent1"/>
+          </a:effectRef>
+          <a:fontRef idx="minor">
+            <a:schemeClr val="lt1"/>
+          </a:fontRef>
+        </p:style>
+        <p:txBody>
+          <a:bodyPr rtlCol="0" anchor="ctr"/>
+          <a:lstStyle/>
+          <a:p>
+            <a:pPr algn="ctr"/>
+          </a:p>
+        </p:txBody>
+      </p:sp>
+      <p:sp>
+        <p:nvSpPr>
+          <p:cNvPr id="8" name="TextBox 7"/>
+          <p:cNvSpPr txBox="1"/>
+          <p:nvPr/>
+        </p:nvSpPr>
+        <p:spPr>
+          <a:xfrm>
+            <a:off x="10667390" y="329184"/>
+            <a:ext cx="927201" cy="329184"/>
+          </a:xfrm>
+          <a:prstGeom prst="rect">
+            <a:avLst/>
+          </a:prstGeom>
           <a:noFill/>
         </p:spPr>
         <p:txBody>
-          <a:bodyPr wrap="square" anchor="t" lIns="54864" rIns="54864" tIns="18288" bIns="18288">
+          <a:bodyPr wrap="square" anchor="ctr" lIns="54864" rIns="54864" tIns="18288" bIns="18288">
             <a:spAutoFit/>
           </a:bodyPr>
           <a:lstStyle/>
@@ -8286,41 +8124,17 @@
               </a:spcAft>
             </a:pPr>
             <a:r>
-              <a:rPr sz="1300" b="1">
+              <a:rPr sz="1050" b="1">
                 <a:solidFill>
                   <a:srgbClr val="D40511"/>
                 </a:solidFill>
                 <a:latin typeface="Calibri"/>
               </a:rPr>
-              <a:t>AVERAGE VS PEAK, BY METRIC</a:t>
-            </a:r>
-          </a:p>
-        </p:txBody>
-      </p:sp>
-      <p:pic>
-        <p:nvPicPr>
-          <p:cNvPr id="8" name="Picture 7" descr="peak_chart.png"/>
-          <p:cNvPicPr>
-            <a:picLocks noChangeAspect="1"/>
-          </p:cNvPicPr>
-          <p:nvPr/>
-        </p:nvPicPr>
-        <p:blipFill>
-          <a:blip r:embed="rId2"/>
-          <a:stretch>
-            <a:fillRect/>
-          </a:stretch>
-        </p:blipFill>
-        <p:spPr>
-          <a:xfrm>
-            <a:off x="590813" y="1600200"/>
-            <a:ext cx="5402052" cy="3246120"/>
-          </a:xfrm>
-          <a:prstGeom prst="rect">
-            <a:avLst/>
-          </a:prstGeom>
-        </p:spPr>
-      </p:pic>
+              <a:t>ANALYSIS</a:t>
+            </a:r>
+          </a:p>
+        </p:txBody>
+      </p:sp>
       <p:sp>
         <p:nvSpPr>
           <p:cNvPr id="9" name="TextBox 8"/>
@@ -8329,8 +8143,8 @@
         </p:nvSpPr>
         <p:spPr>
           <a:xfrm>
-            <a:off x="566928" y="4846320"/>
-            <a:ext cx="5486400" cy="365760"/>
+            <a:off x="566928" y="1664208"/>
+            <a:ext cx="5029200" cy="320040"/>
           </a:xfrm>
           <a:prstGeom prst="rect">
             <a:avLst/>
@@ -8355,27 +8169,51 @@
               </a:spcAft>
             </a:pPr>
             <a:r>
-              <a:rPr sz="1050" b="0">
-                <a:solidFill>
-                  <a:srgbClr val="6B7280"/>
-                </a:solidFill>
-                <a:latin typeface="Calibri"/>
-              </a:rPr>
-              <a:t>Units shown ÷100 so all four metrics sit on a comparable scale.</a:t>
-            </a:r>
-          </a:p>
-        </p:txBody>
-      </p:sp>
-      <p:sp>
-        <p:nvSpPr>
-          <p:cNvPr id="10" name="TextBox 9"/>
+              <a:rPr sz="1300" b="1">
+                <a:solidFill>
+                  <a:srgbClr val="D40511"/>
+                </a:solidFill>
+                <a:latin typeface="Calibri"/>
+              </a:rPr>
+              <a:t>A NORMAL DAY VS THE BUSIEST DAY</a:t>
+            </a:r>
+          </a:p>
+        </p:txBody>
+      </p:sp>
+      <p:pic>
+        <p:nvPicPr>
+          <p:cNvPr id="10" name="Picture 9" descr="peak_chart.png"/>
+          <p:cNvPicPr>
+            <a:picLocks noChangeAspect="1"/>
+          </p:cNvPicPr>
+          <p:nvPr/>
+        </p:nvPicPr>
+        <p:blipFill>
+          <a:blip r:embed="rId2"/>
+          <a:stretch>
+            <a:fillRect/>
+          </a:stretch>
+        </p:blipFill>
+        <p:spPr>
+          <a:xfrm>
+            <a:off x="895154" y="2011680"/>
+            <a:ext cx="4793370" cy="2880360"/>
+          </a:xfrm>
+          <a:prstGeom prst="rect">
+            <a:avLst/>
+          </a:prstGeom>
+        </p:spPr>
+      </p:pic>
+      <p:sp>
+        <p:nvSpPr>
+          <p:cNvPr id="11" name="TextBox 10"/>
           <p:cNvSpPr txBox="1"/>
           <p:nvPr/>
         </p:nvSpPr>
         <p:spPr>
           <a:xfrm>
-            <a:off x="6446520" y="1234440"/>
-            <a:ext cx="5029200" cy="320040"/>
+            <a:off x="566928" y="4892040"/>
+            <a:ext cx="5486400" cy="365760"/>
           </a:xfrm>
           <a:prstGeom prst="rect">
             <a:avLst/>
@@ -8400,27 +8238,72 @@
               </a:spcAft>
             </a:pPr>
             <a:r>
+              <a:rPr sz="1050" b="0">
+                <a:solidFill>
+                  <a:srgbClr val="6B7280"/>
+                </a:solidFill>
+                <a:latin typeface="Calibri"/>
+              </a:rPr>
+              <a:t>Pieces are shown ÷100 so all four bars fit on one scale.</a:t>
+            </a:r>
+          </a:p>
+        </p:txBody>
+      </p:sp>
+      <p:sp>
+        <p:nvSpPr>
+          <p:cNvPr id="12" name="TextBox 11"/>
+          <p:cNvSpPr txBox="1"/>
+          <p:nvPr/>
+        </p:nvSpPr>
+        <p:spPr>
+          <a:xfrm>
+            <a:off x="6446520" y="1664208"/>
+            <a:ext cx="5029200" cy="320040"/>
+          </a:xfrm>
+          <a:prstGeom prst="rect">
+            <a:avLst/>
+          </a:prstGeom>
+          <a:noFill/>
+        </p:spPr>
+        <p:txBody>
+          <a:bodyPr wrap="square" anchor="t" lIns="54864" rIns="54864" tIns="18288" bIns="18288">
+            <a:spAutoFit/>
+          </a:bodyPr>
+          <a:lstStyle/>
+          <a:p>
+            <a:pPr algn="l">
+              <a:lnSpc>
+                <a:spcPct val="100000"/>
+              </a:lnSpc>
+              <a:spcBef>
+                <a:spcPts val="0"/>
+              </a:spcBef>
+              <a:spcAft>
+                <a:spcPts val="400"/>
+              </a:spcAft>
+            </a:pPr>
+            <a:r>
               <a:rPr sz="1300" b="1">
                 <a:solidFill>
                   <a:srgbClr val="D40511"/>
                 </a:solidFill>
                 <a:latin typeface="Calibri"/>
               </a:rPr>
-              <a:t>PEAK ACTIVITY DETAIL</a:t>
+              <a:t>THE NUMBERS</a:t>
             </a:r>
           </a:p>
         </p:txBody>
       </p:sp>
       <p:graphicFrame>
         <p:nvGraphicFramePr>
-          <p:cNvPr id="11" name="Table 10"/>
+          <p:cNvPr id="13" name="Table 12"/>
           <p:cNvGraphicFramePr>
             <a:graphicFrameLocks noGrp="1"/>
           </p:cNvGraphicFramePr>
           <p:nvPr/>
         </p:nvGraphicFramePr>
         <p:xfrm>
-          <a:off x="6446520" y="1627632"/>
+          <a:off x="6446520" y="2011680"/>
           <a:ext cx="5166360" cy="1783080"/>
         </p:xfrm>
         <a:graphic>
@@ -8450,7 +8333,7 @@
                           </a:solidFill>
                           <a:latin typeface="Calibri"/>
                         </a:rPr>
-                        <a:t>Metric</a:t>
+                        <a:t/>
                       </a:r>
                     </a:p>
                   </a:txBody>
@@ -8473,7 +8356,7 @@
                           </a:solidFill>
                           <a:latin typeface="Calibri"/>
                         </a:rPr>
-                        <a:t>Average/day</a:t>
+                        <a:t>Normal day</a:t>
                       </a:r>
                     </a:p>
                   </a:txBody>
@@ -8496,7 +8379,7 @@
                           </a:solidFill>
                           <a:latin typeface="Calibri"/>
                         </a:rPr>
-                        <a:t>Peak/day</a:t>
+                        <a:t>Busiest day</a:t>
                       </a:r>
                     </a:p>
                   </a:txBody>
@@ -8519,7 +8402,7 @@
                           </a:solidFill>
                           <a:latin typeface="Calibri"/>
                         </a:rPr>
-                        <a:t>Peak÷Avg</a:t>
+                        <a:t>How much more</a:t>
                       </a:r>
                     </a:p>
                   </a:txBody>
@@ -8542,7 +8425,7 @@
                           </a:solidFill>
                           <a:latin typeface="Calibri"/>
                         </a:rPr>
-                        <a:t>Peak date</a:t>
+                        <a:t>When</a:t>
                       </a:r>
                     </a:p>
                   </a:txBody>
@@ -8636,7 +8519,7 @@
                           </a:solidFill>
                           <a:latin typeface="Calibri"/>
                         </a:rPr>
-                        <a:t>1.83×</a:t>
+                        <a:t>1.8×</a:t>
                       </a:r>
                     </a:p>
                   </a:txBody>
@@ -8684,7 +8567,7 @@
                           </a:solidFill>
                           <a:latin typeface="Calibri"/>
                         </a:rPr>
-                        <a:t>Units</a:t>
+                        <a:t>Pieces</a:t>
                       </a:r>
                     </a:p>
                   </a:txBody>
@@ -8753,7 +8636,7 @@
                           </a:solidFill>
                           <a:latin typeface="Calibri"/>
                         </a:rPr>
-                        <a:t>2.85×</a:t>
+                        <a:t>2.9×</a:t>
                       </a:r>
                     </a:p>
                   </a:txBody>
@@ -8870,7 +8753,7 @@
                           </a:solidFill>
                           <a:latin typeface="Calibri"/>
                         </a:rPr>
-                        <a:t>1.74×</a:t>
+                        <a:t>1.7×</a:t>
                       </a:r>
                     </a:p>
                   </a:txBody>
@@ -8987,7 +8870,7 @@
                           </a:solidFill>
                           <a:latin typeface="Calibri"/>
                         </a:rPr>
-                        <a:t>1.71×</a:t>
+                        <a:t>1.7×</a:t>
                       </a:r>
                     </a:p>
                   </a:txBody>
@@ -9027,13 +8910,13 @@
       </p:graphicFrame>
       <p:sp>
         <p:nvSpPr>
-          <p:cNvPr id="12" name="TextBox 11"/>
+          <p:cNvPr id="14" name="TextBox 13"/>
           <p:cNvSpPr txBox="1"/>
           <p:nvPr/>
         </p:nvSpPr>
         <p:spPr>
           <a:xfrm>
-            <a:off x="6446520" y="3611880"/>
+            <a:off x="6446520" y="3977639"/>
             <a:ext cx="5166360" cy="822960"/>
           </a:xfrm>
           <a:prstGeom prst="rect">
@@ -9065,7 +8948,7 @@
                 </a:solidFill>
                 <a:latin typeface="Calibri"/>
               </a:rPr>
-              <a:t>Design to peak, not average. </a:t>
+              <a:t>Plan for the busy days. </a:t>
             </a:r>
             <a:r>
               <a:rPr sz="1250" b="0">
@@ -9074,14 +8957,14 @@
                 </a:solidFill>
                 <a:latin typeface="Calibri"/>
               </a:rPr>
-              <a:t>Units peak 2.85× vs order lines 1.83× — sizing on lines alone understates pick/pack and MHE surges.</a:t>
-            </a:r>
-          </a:p>
-        </p:txBody>
-      </p:sp>
-      <p:sp>
-        <p:nvSpPr>
-          <p:cNvPr id="13" name="Rounded Rectangle 12"/>
+              <a:t>On the busiest day the warehouse shipped nearly 3× the usual pieces, so it needs spare capacity.</a:t>
+            </a:r>
+          </a:p>
+        </p:txBody>
+      </p:sp>
+      <p:sp>
+        <p:nvSpPr>
+          <p:cNvPr id="15" name="Rounded Rectangle 14"/>
           <p:cNvSpPr/>
           <p:nvPr/>
         </p:nvSpPr>
@@ -9133,7 +9016,7 @@
       </p:sp>
       <p:sp>
         <p:nvSpPr>
-          <p:cNvPr id="14" name="Rounded Rectangle 13"/>
+          <p:cNvPr id="16" name="Rounded Rectangle 15"/>
           <p:cNvSpPr/>
           <p:nvPr/>
         </p:nvSpPr>
@@ -9179,7 +9062,7 @@
       </p:sp>
       <p:sp>
         <p:nvSpPr>
-          <p:cNvPr id="15" name="TextBox 14"/>
+          <p:cNvPr id="17" name="TextBox 16"/>
           <p:cNvSpPr txBox="1"/>
           <p:nvPr/>
         </p:nvSpPr>
@@ -9217,14 +9100,14 @@
                 </a:solidFill>
                 <a:latin typeface="Calibri"/>
               </a:rPr>
-              <a:t>Weekly peak</a:t>
-            </a:r>
-          </a:p>
-        </p:txBody>
-      </p:sp>
-      <p:sp>
-        <p:nvSpPr>
-          <p:cNvPr id="16" name="TextBox 15"/>
+              <a:t>Busy weeks too</a:t>
+            </a:r>
+          </a:p>
+        </p:txBody>
+      </p:sp>
+      <p:sp>
+        <p:nvSpPr>
+          <p:cNvPr id="18" name="TextBox 17"/>
           <p:cNvSpPr txBox="1"/>
           <p:nvPr/>
         </p:nvSpPr>
@@ -9256,6 +9139,15 @@
               </a:spcAft>
             </a:pPr>
             <a:r>
+              <a:rPr sz="1150" b="0">
+                <a:solidFill>
+                  <a:srgbClr val="262626"/>
+                </a:solidFill>
+                <a:latin typeface="Calibri"/>
+              </a:rPr>
+              <a:t>The busiest week handled </a:t>
+            </a:r>
+            <a:r>
               <a:rPr sz="1150" b="1">
                 <a:solidFill>
                   <a:srgbClr val="262626"/>
@@ -9271,14 +9163,14 @@
                 </a:solidFill>
                 <a:latin typeface="Calibri"/>
               </a:rPr>
-              <a:t> in the week of 01-Jun vs ~2,791 average — a sustained surge, not one spike day.</a:t>
-            </a:r>
-          </a:p>
-        </p:txBody>
-      </p:sp>
-      <p:sp>
-        <p:nvSpPr>
-          <p:cNvPr id="17" name="Rounded Rectangle 16"/>
+              <a:t> vs ~2,791 normally — a busy spell, not just one day.</a:t>
+            </a:r>
+          </a:p>
+        </p:txBody>
+      </p:sp>
+      <p:sp>
+        <p:nvSpPr>
+          <p:cNvPr id="19" name="Rounded Rectangle 18"/>
           <p:cNvSpPr/>
           <p:nvPr/>
         </p:nvSpPr>
@@ -9330,7 +9222,7 @@
       </p:sp>
       <p:sp>
         <p:nvSpPr>
-          <p:cNvPr id="18" name="Rounded Rectangle 17"/>
+          <p:cNvPr id="20" name="Rounded Rectangle 19"/>
           <p:cNvSpPr/>
           <p:nvPr/>
         </p:nvSpPr>
@@ -9376,7 +9268,7 @@
       </p:sp>
       <p:sp>
         <p:nvSpPr>
-          <p:cNvPr id="19" name="TextBox 18"/>
+          <p:cNvPr id="21" name="TextBox 20"/>
           <p:cNvSpPr txBox="1"/>
           <p:nvPr/>
         </p:nvSpPr>
@@ -9414,14 +9306,14 @@
                 </a:solidFill>
                 <a:latin typeface="Calibri"/>
               </a:rPr>
-              <a:t>Intraday peak</a:t>
-            </a:r>
-          </a:p>
-        </p:txBody>
-      </p:sp>
-      <p:sp>
-        <p:nvSpPr>
-          <p:cNvPr id="20" name="TextBox 19"/>
+              <a:t>Busy times of day</a:t>
+            </a:r>
+          </a:p>
+        </p:txBody>
+      </p:sp>
+      <p:sp>
+        <p:nvSpPr>
+          <p:cNvPr id="22" name="TextBox 21"/>
           <p:cNvSpPr txBox="1"/>
           <p:nvPr/>
         </p:nvSpPr>
@@ -9459,7 +9351,7 @@
                 </a:solidFill>
                 <a:latin typeface="Calibri"/>
               </a:rPr>
-              <a:t>Picking peaks ~08:00</a:t>
+              <a:t>Picking is busiest around 08:00.</a:t>
             </a:r>
             <a:r>
               <a:rPr sz="1150" b="0">
@@ -9468,14 +9360,14 @@
                 </a:solidFill>
                 <a:latin typeface="Calibri"/>
               </a:rPr>
-              <a:t>. Mon–Fri only (no weekend); weekday volumes otherwise even.</a:t>
-            </a:r>
-          </a:p>
-        </p:txBody>
-      </p:sp>
-      <p:sp>
-        <p:nvSpPr>
-          <p:cNvPr id="21" name="TextBox 20"/>
+              <a:t> The warehouse runs Mon–Fri, no weekends.</a:t>
+            </a:r>
+          </a:p>
+        </p:txBody>
+      </p:sp>
+      <p:sp>
+        <p:nvSpPr>
+          <p:cNvPr id="23" name="TextBox 22"/>
           <p:cNvSpPr txBox="1"/>
           <p:nvPr/>
         </p:nvSpPr>
@@ -9520,7 +9412,7 @@
       </p:sp>
       <p:sp>
         <p:nvSpPr>
-          <p:cNvPr id="22" name="TextBox 21"/>
+          <p:cNvPr id="24" name="TextBox 23"/>
           <p:cNvSpPr txBox="1"/>
           <p:nvPr/>
         </p:nvSpPr>
@@ -9665,7 +9557,7 @@
                 </a:solidFill>
                 <a:latin typeface="Calibri"/>
               </a:rPr>
-              <a:t>Storage Sizing &amp; Feasibility</a:t>
+              <a:t>How Much Storage We Need</a:t>
             </a:r>
           </a:p>
         </p:txBody>
@@ -9710,7 +9602,7 @@
                 </a:solidFill>
                 <a:latin typeface="Calibri"/>
               </a:rPr>
-              <a:t>Sizing to the defensible pallet-position basis</a:t>
+              <a:t>Sizing the warehouse on solid numbers</a:t>
             </a:r>
           </a:p>
         </p:txBody>
@@ -10035,7 +9927,7 @@
                 </a:solidFill>
                 <a:latin typeface="Calibri"/>
               </a:rPr>
-              <a:t>Peak positions (occupied)</a:t>
+              <a:t>Pallet spaces at peak</a:t>
             </a:r>
           </a:p>
         </p:txBody>
@@ -10179,7 +10071,7 @@
                 </a:solidFill>
                 <a:latin typeface="Calibri"/>
               </a:rPr>
-              <a:t>Design target (÷90% util.)</a:t>
+              <a:t>Spaces we'll build for</a:t>
             </a:r>
           </a:p>
         </p:txBody>
@@ -10323,7 +10215,7 @@
                 </a:solidFill>
                 <a:latin typeface="Calibri"/>
               </a:rPr>
-              <a:t>Levels under 12.2 m</a:t>
+              <a:t>Levels high (up to 12.2 m)</a:t>
             </a:r>
           </a:p>
         </p:txBody>
@@ -10466,7 +10358,7 @@
                 </a:solidFill>
                 <a:latin typeface="Calibri"/>
               </a:rPr>
-              <a:t>Position basis (corrected)</a:t>
+              <a:t>How we sized it</a:t>
             </a:r>
           </a:p>
         </p:txBody>
@@ -10520,7 +10412,7 @@
                 </a:solidFill>
                 <a:latin typeface="Calibri"/>
               </a:rPr>
-              <a:t>Baseline = peak occupied locations ≈ 8,512</a:t>
+              <a:t>The busiest day used ~8,500 pallet spaces</a:t>
             </a:r>
             <a:r>
               <a:rPr sz="1250" b="0">
@@ -10529,7 +10421,7 @@
                 </a:solidFill>
                 <a:latin typeface="Calibri"/>
               </a:rPr>
-              <a:t> (not the 11,015 loads)</a:t>
+              <a:t> — that's the real need</a:t>
             </a:r>
           </a:p>
           <a:p>
@@ -10560,7 +10452,7 @@
                 </a:solidFill>
                 <a:latin typeface="Calibri"/>
               </a:rPr>
-              <a:t>Design provision ≈ 9,500</a:t>
+              <a:t>We plan for ~9,500</a:t>
             </a:r>
             <a:r>
               <a:rPr sz="1250" b="0">
@@ -10569,7 +10461,7 @@
                 </a:solidFill>
                 <a:latin typeface="Calibri"/>
               </a:rPr>
-              <a:t> at 90% working utilisation</a:t>
+              <a:t> so racks are never 100% full (easier to work)</a:t>
             </a:r>
           </a:p>
           <a:p>
@@ -10594,31 +10486,22 @@
               <a:t>•  </a:t>
             </a:r>
             <a:r>
+              <a:rPr sz="1250" b="1">
+                <a:solidFill>
+                  <a:srgbClr val="262626"/>
+                </a:solidFill>
+                <a:latin typeface="Calibri"/>
+              </a:rPr>
+              <a:t>Growth is handled by tall racks</a:t>
+            </a:r>
+            <a:r>
               <a:rPr sz="1250" b="0">
                 <a:solidFill>
                   <a:srgbClr val="262626"/>
                 </a:solidFill>
                 <a:latin typeface="Calibri"/>
               </a:rPr>
-              <a:t>+8.2%/qtr growth </a:t>
-            </a:r>
-            <a:r>
-              <a:rPr sz="1250" b="1">
-                <a:solidFill>
-                  <a:srgbClr val="262626"/>
-                </a:solidFill>
-                <a:latin typeface="Calibri"/>
-              </a:rPr>
-              <a:t>absorbed by rack headroom</a:t>
-            </a:r>
-            <a:r>
-              <a:rPr sz="1250" b="0">
-                <a:solidFill>
-                  <a:srgbClr val="262626"/>
-                </a:solidFill>
-                <a:latin typeface="Calibri"/>
-              </a:rPr>
-              <a:t>, not an inflated count</a:t>
+              <a:t>, not by adding a big safety number</a:t>
             </a:r>
           </a:p>
           <a:p>
@@ -10649,7 +10532,7 @@
                 </a:solidFill>
                 <a:latin typeface="Calibri"/>
               </a:rPr>
-              <a:t>Retires the earlier 14,074 figure</a:t>
+              <a:t>This replaces our earlier 14,074</a:t>
             </a:r>
             <a:r>
               <a:rPr sz="1250" b="0">
@@ -10658,7 +10541,7 @@
                 </a:solidFill>
                 <a:latin typeface="Calibri"/>
               </a:rPr>
-              <a:t> (indefensible +5,574 buffer)</a:t>
+              <a:t> — too high, per the feedback</a:t>
             </a:r>
           </a:p>
         </p:txBody>
@@ -10679,8 +10562,8 @@
         </p:blipFill>
         <p:spPr>
           <a:xfrm>
-            <a:off x="6465847" y="2926080"/>
-            <a:ext cx="4487625" cy="2697480"/>
+            <a:off x="6474021" y="2926080"/>
+            <a:ext cx="4471277" cy="2697480"/>
           </a:xfrm>
           <a:prstGeom prst="rect">
             <a:avLst/>
@@ -10727,7 +10610,7 @@
                 </a:solidFill>
                 <a:latin typeface="Calibri"/>
               </a:rPr>
-              <a:t>Storage + 35% functional allowance, scaled to ~9,500 positions.</a:t>
+              <a:t>Floor space each storage style needs vs the 7,000 m² limit.</a:t>
             </a:r>
           </a:p>
         </p:txBody>
@@ -10824,7 +10707,7 @@
                 </a:solidFill>
                 <a:latin typeface="Calibri"/>
               </a:rPr>
-              <a:t>Even without a growth buffer, double-deep uses only ~61% of the envelope</a:t>
+              <a:t>Two-deep racking fills only ~61% of the space</a:t>
             </a:r>
             <a:r>
               <a:rPr sz="1300" b="0">
@@ -10833,7 +10716,7 @@
                 </a:solidFill>
                 <a:latin typeface="Calibri"/>
               </a:rPr>
-              <a:t> → ample headroom; the choice is driven by productivity, not just fit.</a:t>
+              <a:t> — plenty of room. So we choose on efficiency, not just fitting in.</a:t>
             </a:r>
           </a:p>
         </p:txBody>
@@ -10985,7 +10868,7 @@
                 </a:solidFill>
                 <a:latin typeface="Calibri"/>
               </a:rPr>
-              <a:t>Design Options &amp; Why Option B</a:t>
+              <a:t>Three Options — and Why We Pick B</a:t>
             </a:r>
           </a:p>
         </p:txBody>
@@ -11030,7 +10913,7 @@
                 </a:solidFill>
                 <a:latin typeface="Calibri"/>
               </a:rPr>
-              <a:t>Aligned choices across receiving, storage, picking &amp; shipping</a:t>
+              <a:t>Every choice works together across the whole warehouse</a:t>
             </a:r>
           </a:p>
         </p:txBody>
@@ -11354,7 +11237,7 @@
                 </a:solidFill>
                 <a:latin typeface="Calibri"/>
               </a:rPr>
-              <a:t>Option A — Conventional+</a:t>
+              <a:t>Option A — Keep it simple</a:t>
             </a:r>
           </a:p>
         </p:txBody>
@@ -11408,7 +11291,7 @@
                 </a:solidFill>
                 <a:latin typeface="Calibri"/>
               </a:rPr>
-              <a:t>Narrow-aisle selective</a:t>
+              <a:t>Normal racks, narrow aisles</a:t>
             </a:r>
           </a:p>
           <a:p>
@@ -11439,7 +11322,7 @@
                 </a:solidFill>
                 <a:latin typeface="Calibri"/>
               </a:rPr>
-              <a:t>Discrete + batch picking</a:t>
+              <a:t>Pick orders one by one</a:t>
             </a:r>
           </a:p>
           <a:p>
@@ -11470,7 +11353,7 @@
                 </a:solidFill>
                 <a:latin typeface="Calibri"/>
               </a:rPr>
-              <a:t>≈72% of envelope</a:t>
+              <a:t>Uses ~72% of the space</a:t>
             </a:r>
           </a:p>
           <a:p>
@@ -11501,7 +11384,7 @@
                 </a:solidFill>
                 <a:latin typeface="Calibri"/>
               </a:rPr>
-              <a:t>Lowest CAPEX · most travel</a:t>
+              <a:t>Cheapest, but most walking</a:t>
             </a:r>
           </a:p>
         </p:txBody>
@@ -11644,7 +11527,7 @@
                 </a:solidFill>
                 <a:latin typeface="Calibri"/>
               </a:rPr>
-              <a:t>Option B — Hybrid Density  ✓</a:t>
+              <a:t>Option B — Best balance  ✓</a:t>
             </a:r>
           </a:p>
         </p:txBody>
@@ -11698,7 +11581,7 @@
                 </a:solidFill>
                 <a:latin typeface="Calibri"/>
               </a:rPr>
-              <a:t>Double-deep + forward pick</a:t>
+              <a:t>Two-deep racks + fast-pick area</a:t>
             </a:r>
           </a:p>
           <a:p>
@@ -11729,7 +11612,7 @@
                 </a:solidFill>
                 <a:latin typeface="Calibri"/>
               </a:rPr>
-              <a:t>Zone + batch/wave picking</a:t>
+              <a:t>Pickers work zones, many orders/trip</a:t>
             </a:r>
           </a:p>
           <a:p>
@@ -11760,7 +11643,7 @@
                 </a:solidFill>
                 <a:latin typeface="Calibri"/>
               </a:rPr>
-              <a:t>≈61% of envelope · room to grow</a:t>
+              <a:t>Uses ~61%, room to grow</a:t>
             </a:r>
           </a:p>
           <a:p>
@@ -11791,7 +11674,7 @@
                 </a:solidFill>
                 <a:latin typeface="Calibri"/>
               </a:rPr>
-              <a:t>Best space/productivity balance</a:t>
+              <a:t>Best mix of space &amp; effort</a:t>
             </a:r>
           </a:p>
         </p:txBody>
@@ -11934,7 +11817,7 @@
                 </a:solidFill>
                 <a:latin typeface="Calibri"/>
               </a:rPr>
-              <a:t>Option C — Semi-Automated</a:t>
+              <a:t>Option C — Automated</a:t>
             </a:r>
           </a:p>
         </p:txBody>
@@ -11988,7 +11871,7 @@
                 </a:solidFill>
                 <a:latin typeface="Calibri"/>
               </a:rPr>
-              <a:t>VNA + automated smalls</a:t>
+              <a:t>Very narrow aisles + machines</a:t>
             </a:r>
           </a:p>
           <a:p>
@@ -12019,7 +11902,7 @@
                 </a:solidFill>
                 <a:latin typeface="Calibri"/>
               </a:rPr>
-              <a:t>Goods-to-person / PTL</a:t>
+              <a:t>Machines bring items to pickers</a:t>
             </a:r>
           </a:p>
           <a:p>
@@ -12050,7 +11933,7 @@
                 </a:solidFill>
                 <a:latin typeface="Calibri"/>
               </a:rPr>
-              <a:t>≈48% of envelope (densest)</a:t>
+              <a:t>Uses ~48% (tightest)</a:t>
             </a:r>
           </a:p>
           <a:p>
@@ -12081,7 +11964,7 @@
                 </a:solidFill>
                 <a:latin typeface="Calibri"/>
               </a:rPr>
-              <a:t>Highest CAPEX &amp; complexity</a:t>
+              <a:t>Most expensive &amp; complex</a:t>
             </a:r>
           </a:p>
         </p:txBody>
@@ -12126,7 +12009,7 @@
                 </a:solidFill>
                 <a:latin typeface="Calibri"/>
               </a:rPr>
-              <a:t>WHY OPTION B — DATA FINDING → DESIGN DECISION</a:t>
+              <a:t>WHY OPTION B — WHAT WE FOUND → WHAT WE DECIDED</a:t>
             </a:r>
           </a:p>
         </p:txBody>
@@ -12217,7 +12100,7 @@
                 </a:solidFill>
                 <a:latin typeface="Calibri"/>
               </a:rPr>
-              <a:t>73% single-load C tail + growth headroom</a:t>
+              <a:t>Many slow sellers + need room to grow</a:t>
             </a:r>
           </a:p>
         </p:txBody>
@@ -12399,7 +12282,7 @@
                 </a:solidFill>
                 <a:latin typeface="Calibri"/>
               </a:rPr>
-              <a:t>Double-deep reserve — dense, few aisles, low travel</a:t>
+              <a:t>Store pallets two-deep — saves space, less walking</a:t>
             </a:r>
           </a:p>
         </p:txBody>
@@ -12490,7 +12373,7 @@
                 </a:solidFill>
                 <a:latin typeface="Calibri"/>
               </a:rPr>
-              <a:t>41% each-only, small lines &amp; orders</a:t>
+              <a:t>Lots of single pieces and small orders</a:t>
             </a:r>
           </a:p>
         </p:txBody>
@@ -12672,7 +12555,7 @@
                 </a:solidFill>
                 <a:latin typeface="Calibri"/>
               </a:rPr>
-              <a:t>Forward-pick module (carton-flow) for fast case/each</a:t>
+              <a:t>A small fast-pick area near the door</a:t>
             </a:r>
           </a:p>
         </p:txBody>
@@ -12763,7 +12646,7 @@
                 </a:solidFill>
                 <a:latin typeface="Calibri"/>
               </a:rPr>
-              <a:t>Only 48.6% ABC agreement with WMS</a:t>
+              <a:t>Best-sellers stored in the wrong places</a:t>
             </a:r>
           </a:p>
         </p:txBody>
@@ -12945,7 +12828,7 @@
                 </a:solidFill>
                 <a:latin typeface="Calibri"/>
               </a:rPr>
-              <a:t>Demand-based velocity slotting (golden zone)</a:t>
+              <a:t>Put the most-ordered items closest</a:t>
             </a:r>
           </a:p>
         </p:txBody>
@@ -13036,7 +12919,7 @@
                 </a:solidFill>
                 <a:latin typeface="Calibri"/>
               </a:rPr>
-              <a:t>50% single-line orders</a:t>
+              <a:t>Half of orders are for one product</a:t>
             </a:r>
           </a:p>
         </p:txBody>
@@ -13218,7 +13101,7 @@
                 </a:solidFill>
                 <a:latin typeface="Calibri"/>
               </a:rPr>
-              <a:t>Zone + batch/wave picking — biggest labour lever</a:t>
+              <a:t>Pickers collect several orders per trip</a:t>
             </a:r>
           </a:p>
         </p:txBody>
@@ -13309,7 +13192,7 @@
                 </a:solidFill>
                 <a:latin typeface="Calibri"/>
               </a:rPr>
-              <a:t>138 hazardous + 168 XLONG pallets</a:t>
+              <a:t>Some hazardous and some very long items</a:t>
             </a:r>
           </a:p>
         </p:txBody>
@@ -13491,7 +13374,7 @@
                 </a:solidFill>
                 <a:latin typeface="Calibri"/>
               </a:rPr>
-              <a:t>Segregation + cantilever for long goods</a:t>
+              <a:t>Separate area + special long-item racks</a:t>
             </a:r>
           </a:p>
         </p:txBody>
@@ -13582,7 +13465,7 @@
                 </a:solidFill>
                 <a:latin typeface="Calibri"/>
               </a:rPr>
-              <a:t>Peak 2.85× units vs average</a:t>
+              <a:t>Busiest day ~3× the average</a:t>
             </a:r>
           </a:p>
         </p:txBody>
@@ -13764,7 +13647,7 @@
                 </a:solidFill>
                 <a:latin typeface="Calibri"/>
               </a:rPr>
-              <a:t>Pick/pack area &amp; MHE sized to peak</a:t>
+              <a:t>Size the pack &amp; ship area for busy days</a:t>
             </a:r>
           </a:p>
         </p:txBody>
@@ -13961,7 +13844,7 @@
                 </a:solidFill>
                 <a:latin typeface="Calibri"/>
               </a:rPr>
-              <a:t>Recommended Layout — Option B</a:t>
+              <a:t>Our Recommended Layout</a:t>
             </a:r>
           </a:p>
         </p:txBody>
@@ -14006,7 +13889,7 @@
                 </a:solidFill>
                 <a:latin typeface="Calibri"/>
               </a:rPr>
-              <a:t>Rack-level floor plan with full order flow, to scale</a:t>
+              <a:t>The full floor plan, drawn to scale, showing how goods move</a:t>
             </a:r>
           </a:p>
         </p:txBody>
@@ -14208,8 +14091,8 @@
         </p:blipFill>
         <p:spPr>
           <a:xfrm>
-            <a:off x="946683" y="1600200"/>
-            <a:ext cx="6610552" cy="4937760"/>
+            <a:off x="1117993" y="1600200"/>
+            <a:ext cx="6267932" cy="4937760"/>
           </a:xfrm>
           <a:prstGeom prst="rect">
             <a:avLst/>
@@ -14354,7 +14237,7 @@
                 </a:solidFill>
                 <a:latin typeface="Calibri"/>
               </a:rPr>
-              <a:t>Zoning</a:t>
+              <a:t>The areas</a:t>
             </a:r>
           </a:p>
         </p:txBody>
@@ -14408,7 +14291,7 @@
                 </a:solidFill>
                 <a:latin typeface="Calibri"/>
               </a:rPr>
-              <a:t>Double-deep reserve (A/B) for the C tail</a:t>
+              <a:t>Two-deep racks for the many slow sellers</a:t>
             </a:r>
           </a:p>
           <a:p>
@@ -14439,7 +14322,7 @@
                 </a:solidFill>
                 <a:latin typeface="Calibri"/>
               </a:rPr>
-              <a:t>Selective + cantilever for irregular / XLONG</a:t>
+              <a:t>Special racks for odd or long items</a:t>
             </a:r>
           </a:p>
           <a:p>
@@ -14470,7 +14353,7 @@
                 </a:solidFill>
                 <a:latin typeface="Calibri"/>
               </a:rPr>
-              <a:t>Forward-pick module for A/B fast movers</a:t>
+              <a:t>A fast-pick area for the best-sellers</a:t>
             </a:r>
           </a:p>
           <a:p>
@@ -14501,7 +14384,7 @@
                 </a:solidFill>
                 <a:latin typeface="Calibri"/>
               </a:rPr>
-              <a:t>Receiving · Returns/VAS · Pack · Ship · Offices</a:t>
+              <a:t>Goods-in, returns, packing, shipping, offices</a:t>
             </a:r>
           </a:p>
         </p:txBody>
@@ -14644,7 +14527,7 @@
                 </a:solidFill>
                 <a:latin typeface="Calibri"/>
               </a:rPr>
-              <a:t>Flow &amp; fit</a:t>
+              <a:t>How goods move</a:t>
             </a:r>
           </a:p>
         </p:txBody>
@@ -14698,7 +14581,7 @@
                 </a:solidFill>
                 <a:latin typeface="Calibri"/>
               </a:rPr>
-              <a:t>Receive → putaway → replenish → pick → pack → ship</a:t>
+              <a:t>In → put away → refill → pick → pack → out</a:t>
             </a:r>
           </a:p>
           <a:p>
@@ -14729,7 +14612,7 @@
                 </a:solidFill>
                 <a:latin typeface="Calibri"/>
               </a:rPr>
-              <a:t>Returns (7–9) and cross-dock handled separately</a:t>
+              <a:t>Returns and pass-through goods handled separately</a:t>
             </a:r>
           </a:p>
           <a:p>
@@ -14760,7 +14643,7 @@
                 </a:solidFill>
                 <a:latin typeface="Calibri"/>
               </a:rPr>
-              <a:t>3 receiving + 3 shipping docks</a:t>
+              <a:t>Goods-in and goods-out at opposite ends</a:t>
             </a:r>
             <a:r>
               <a:rPr sz="1130" b="0">
@@ -14769,7 +14652,7 @@
                 </a:solidFill>
                 <a:latin typeface="Calibri"/>
               </a:rPr>
-              <a:t>, opposite ends → straight-through flow</a:t>
+              <a:t> → simple, straight flow</a:t>
             </a:r>
           </a:p>
           <a:p>
@@ -14800,7 +14683,7 @@
                 </a:solidFill>
                 <a:latin typeface="Calibri"/>
               </a:rPr>
-              <a:t>6,541 m² footprint</a:t>
+              <a:t>Uses 6,541 m² (93% of the limit)</a:t>
             </a:r>
             <a:r>
               <a:rPr sz="1130" b="0">
@@ -14809,7 +14692,7 @@
                 </a:solidFill>
                 <a:latin typeface="Calibri"/>
               </a:rPr>
-              <a:t> (93%); ~9,500 positions with headroom</a:t>
+              <a:t>, with room to grow</a:t>
             </a:r>
           </a:p>
         </p:txBody>

</xml_diff>

<commit_message>
Option B layout: keep only main flow arrows (In-put away-refill-pick-pack-out)
Remove returns (7-9) and cross-dock arrows, trim legend to 3, bolder arrows. Co-Authored-By: Claude Opus 4.8 <noreply@anthropic.com>
</commit_message>
<xml_diff>
--- a/deliverables/DHL Group 3 Milestone 1 (v2).pptx
+++ b/deliverables/DHL Group 3 Milestone 1 (v2).pptx
@@ -14091,8 +14091,8 @@
         </p:blipFill>
         <p:spPr>
           <a:xfrm>
-            <a:off x="1117993" y="1600200"/>
-            <a:ext cx="6267932" cy="4937760"/>
+            <a:off x="1662646" y="1600200"/>
+            <a:ext cx="5178626" cy="4937760"/>
           </a:xfrm>
           <a:prstGeom prst="rect">
             <a:avLst/>
@@ -14612,7 +14612,7 @@
                 </a:solidFill>
                 <a:latin typeface="Calibri"/>
               </a:rPr>
-              <a:t>Returns and pass-through goods handled separately</a:t>
+              <a:t>Best-sellers picked from the fast-pick area up front</a:t>
             </a:r>
           </a:p>
           <a:p>

</xml_diff>

<commit_message>
Use AI-generated Option B layout as the main floor plan (slide 8)
Add outputs/figures/layout_main.png and point Recommended Layout slide to it. Co-Authored-By: Claude Opus 4.8 <noreply@anthropic.com>
</commit_message>
<xml_diff>
--- a/deliverables/DHL Group 3 Milestone 1 (v2).pptx
+++ b/deliverables/DHL Group 3 Milestone 1 (v2).pptx
@@ -14077,7 +14077,7 @@
       </p:sp>
       <p:pic>
         <p:nvPicPr>
-          <p:cNvPr id="9" name="Picture 8" descr="orderflow.png"/>
+          <p:cNvPr id="9" name="Picture 8" descr="layout_main.png"/>
           <p:cNvPicPr>
             <a:picLocks noChangeAspect="1"/>
           </p:cNvPicPr>
@@ -14091,8 +14091,8 @@
         </p:blipFill>
         <p:spPr>
           <a:xfrm>
-            <a:off x="1662646" y="1600200"/>
-            <a:ext cx="5178626" cy="4937760"/>
+            <a:off x="1474684" y="1417320"/>
+            <a:ext cx="5463110" cy="5212080"/>
           </a:xfrm>
           <a:prstGeom prst="rect">
             <a:avLst/>

</xml_diff>

<commit_message>
Teacher feedback: inbound (loose containers), dock-door calc, Jungheinrich MHE, 08:00 release
Order-derived pick type; corrected storage basis (8,512 peak / 9,500 target); docks 3 in (west) + 5 out (east); fleet ETV 216i x3, ECE 225 x4, ERE 225 x2; D1, D2, deck, renders and registers aligned.

Co-Authored-By: Claude Opus 5.5 <noreply@anthropic.com>
</commit_message>
<xml_diff>
--- a/deliverables/DHL Group 3 Milestone 1 (v2).pptx
+++ b/deliverables/DHL Group 3 Milestone 1 (v2).pptx
@@ -9306,7 +9306,7 @@
                 </a:solidFill>
                 <a:latin typeface="Calibri"/>
               </a:rPr>
-              <a:t>Busy times of day</a:t>
+              <a:t>Why 08:00 is the busiest hour</a:t>
             </a:r>
           </a:p>
         </p:txBody>
@@ -9351,7 +9351,7 @@
                 </a:solidFill>
                 <a:latin typeface="Calibri"/>
               </a:rPr>
-              <a:t>Picking is busiest around 08:00.</a:t>
+              <a:t>It's the order release, not demand.</a:t>
             </a:r>
             <a:r>
               <a:rPr sz="1150" b="0">
@@ -9360,7 +9360,7 @@
                 </a:solidFill>
                 <a:latin typeface="Calibri"/>
               </a:rPr>
-              <a:t> The warehouse runs Mon–Fri, no weekends.</a:t>
+              <a:t> Afternoon orders are released at 16:00–17:00 and picked next morning. Mon–Fri only.</a:t>
             </a:r>
           </a:p>
         </p:txBody>
@@ -14091,8 +14091,8 @@
         </p:blipFill>
         <p:spPr>
           <a:xfrm>
-            <a:off x="1474684" y="1417320"/>
-            <a:ext cx="5463110" cy="5212080"/>
+            <a:off x="1672975" y="1371600"/>
+            <a:ext cx="5066528" cy="4937760"/>
           </a:xfrm>
           <a:prstGeom prst="rect">
             <a:avLst/>
@@ -14643,7 +14643,7 @@
                 </a:solidFill>
                 <a:latin typeface="Calibri"/>
               </a:rPr>
-              <a:t>Goods-in and goods-out at opposite ends</a:t>
+              <a:t>3 receiving doors (west) + 5 shipping (east)</a:t>
             </a:r>
             <a:r>
               <a:rPr sz="1130" b="0">
@@ -14652,7 +14652,7 @@
                 </a:solidFill>
                 <a:latin typeface="Calibri"/>
               </a:rPr>
-              <a:t> → simple, straight flow</a:t>
+              <a:t> → straight-through flow</a:t>
             </a:r>
           </a:p>
           <a:p>

</xml_diff>